<commit_message>
Update PowerShell presentation file for Intro to PowerShell at 2026 Day of Data - Baton Rouge
</commit_message>
<xml_diff>
--- a/Events/2026/DayofData - Baton Rouge/Intro to Powershell/Intro to Powershell.pptx
+++ b/Events/2026/DayofData - Baton Rouge/Intro to Powershell/Intro to Powershell.pptx
@@ -5,43 +5,50 @@
     <p:sldMasterId id="2147483648" r:id="rId1"/>
   </p:sldMasterIdLst>
   <p:notesMasterIdLst>
-    <p:notesMasterId r:id="rId26"/>
+    <p:notesMasterId r:id="rId28"/>
   </p:notesMasterIdLst>
   <p:sldIdLst>
     <p:sldId id="256" r:id="rId2"/>
     <p:sldId id="263" r:id="rId3"/>
-    <p:sldId id="264" r:id="rId4"/>
-    <p:sldId id="265" r:id="rId5"/>
-    <p:sldId id="266" r:id="rId6"/>
-    <p:sldId id="267" r:id="rId7"/>
-    <p:sldId id="268" r:id="rId8"/>
-    <p:sldId id="269" r:id="rId9"/>
-    <p:sldId id="270" r:id="rId10"/>
-    <p:sldId id="271" r:id="rId11"/>
-    <p:sldId id="272" r:id="rId12"/>
-    <p:sldId id="273" r:id="rId13"/>
-    <p:sldId id="274" r:id="rId14"/>
-    <p:sldId id="275" r:id="rId15"/>
-    <p:sldId id="276" r:id="rId16"/>
-    <p:sldId id="277" r:id="rId17"/>
-    <p:sldId id="278" r:id="rId18"/>
-    <p:sldId id="279" r:id="rId19"/>
-    <p:sldId id="280" r:id="rId20"/>
-    <p:sldId id="281" r:id="rId21"/>
-    <p:sldId id="282" r:id="rId22"/>
-    <p:sldId id="283" r:id="rId23"/>
-    <p:sldId id="284" r:id="rId24"/>
-    <p:sldId id="285" r:id="rId25"/>
+    <p:sldId id="257" r:id="rId4"/>
+    <p:sldId id="264" r:id="rId5"/>
+    <p:sldId id="265" r:id="rId6"/>
+    <p:sldId id="266" r:id="rId7"/>
+    <p:sldId id="267" r:id="rId8"/>
+    <p:sldId id="268" r:id="rId9"/>
+    <p:sldId id="269" r:id="rId10"/>
+    <p:sldId id="270" r:id="rId11"/>
+    <p:sldId id="271" r:id="rId12"/>
+    <p:sldId id="272" r:id="rId13"/>
+    <p:sldId id="273" r:id="rId14"/>
+    <p:sldId id="274" r:id="rId15"/>
+    <p:sldId id="275" r:id="rId16"/>
+    <p:sldId id="276" r:id="rId17"/>
+    <p:sldId id="277" r:id="rId18"/>
+    <p:sldId id="278" r:id="rId19"/>
+    <p:sldId id="279" r:id="rId20"/>
+    <p:sldId id="280" r:id="rId21"/>
+    <p:sldId id="281" r:id="rId22"/>
+    <p:sldId id="282" r:id="rId23"/>
+    <p:sldId id="283" r:id="rId24"/>
+    <p:sldId id="284" r:id="rId25"/>
+    <p:sldId id="285" r:id="rId26"/>
+    <p:sldId id="259" r:id="rId27"/>
   </p:sldIdLst>
   <p:sldSz cx="12192000" cy="6858000"/>
   <p:notesSz cx="6858000" cy="9144000"/>
   <p:embeddedFontLst>
     <p:embeddedFont>
+      <p:font typeface="Berlin Sans FB" panose="020E0602020502020306" pitchFamily="34" charset="0"/>
+      <p:regular r:id="rId29"/>
+      <p:bold r:id="rId30"/>
+    </p:embeddedFont>
+    <p:embeddedFont>
       <p:font typeface="Roboto" panose="02000000000000000000" pitchFamily="2" charset="0"/>
-      <p:regular r:id="rId27"/>
-      <p:bold r:id="rId28"/>
-      <p:italic r:id="rId29"/>
-      <p:boldItalic r:id="rId30"/>
+      <p:regular r:id="rId31"/>
+      <p:bold r:id="rId32"/>
+      <p:italic r:id="rId33"/>
+      <p:boldItalic r:id="rId34"/>
     </p:embeddedFont>
   </p:embeddedFontLst>
   <p:defaultTextStyle>
@@ -278,7 +285,7 @@
       <p15:sldGuideLst xmlns:p15="http://schemas.microsoft.com/office/powerpoint/2012/main"/>
     </p:ext>
     <p:ext uri="http://customooxmlschemas.google.com/">
-      <go:slidesCustomData xmlns="" xmlns:mc="http://schemas.openxmlformats.org/markup-compatibility/2006" xmlns:mv="urn:schemas-microsoft-com:mac:vml" xmlns:c="http://schemas.openxmlformats.org/drawingml/2006/chart" xmlns:dgm="http://schemas.openxmlformats.org/drawingml/2006/diagram" xmlns:o="urn:schemas-microsoft-com:office:office" xmlns:v="urn:schemas-microsoft-com:vml" xmlns:pvml="urn:schemas-microsoft-com:office:powerpoint" xmlns:com="http://schemas.openxmlformats.org/drawingml/2006/compatibility" xmlns:p14="http://schemas.microsoft.com/office/powerpoint/2010/main" xmlns:p15="http://schemas.microsoft.com/office/powerpoint/2012/main" xmlns:ahyp="http://schemas.microsoft.com/office/drawing/2018/hyperlinkcolor" xmlns:go="http://customooxmlschemas.google.com/" r:id="rId39" roundtripDataSignature="AMtx7mgObtSRP4Y3aSux5NQfV29+0LOS3w=="/>
+      <go:slidesCustomData xmlns:go="http://customooxmlschemas.google.com/" xmlns:ahyp="http://schemas.microsoft.com/office/drawing/2018/hyperlinkcolor" xmlns:p15="http://schemas.microsoft.com/office/powerpoint/2012/main" xmlns:p14="http://schemas.microsoft.com/office/powerpoint/2010/main" xmlns:com="http://schemas.openxmlformats.org/drawingml/2006/compatibility" xmlns:pvml="urn:schemas-microsoft-com:office:powerpoint" xmlns:v="urn:schemas-microsoft-com:vml" xmlns:o="urn:schemas-microsoft-com:office:office" xmlns:dgm="http://schemas.openxmlformats.org/drawingml/2006/diagram" xmlns:c="http://schemas.openxmlformats.org/drawingml/2006/chart" xmlns:mv="urn:schemas-microsoft-com:mac:vml" xmlns:mc="http://schemas.openxmlformats.org/markup-compatibility/2006" xmlns="" r:id="rId39" roundtripDataSignature="AMtx7mgObtSRP4Y3aSux5NQfV29+0LOS3w=="/>
     </p:ext>
   </p:extLst>
 </p:presentation>
@@ -291,129 +298,44 @@
 </p:cmAuthorLst>
 </file>
 
+<file path=ppt/revisionInfo.xml><?xml version="1.0" encoding="utf-8"?>
+<p1510:revInfo xmlns:a="http://schemas.openxmlformats.org/drawingml/2006/main" xmlns:r="http://schemas.openxmlformats.org/officeDocument/2006/relationships" xmlns:p1510="http://schemas.microsoft.com/office/powerpoint/2015/10/main">
+  <p1510:revLst>
+    <p1510:client id="{A71C29DD-730C-4B68-A9C5-63D1638B3E08}" v="2" dt="2026-07-18T11:31:37.028"/>
+  </p1510:revLst>
+</p1510:revInfo>
+</file>
+
 <file path=ppt/changesInfos/changesInfo1.xml><?xml version="1.0" encoding="utf-8"?>
 <pc:chgInfo xmlns:a="http://schemas.openxmlformats.org/drawingml/2006/main" xmlns:r="http://schemas.openxmlformats.org/officeDocument/2006/relationships" xmlns:ac="http://schemas.microsoft.com/office/drawing/2013/main/command" xmlns:pc="http://schemas.microsoft.com/office/powerpoint/2013/main/command">
   <pc:docChgLst>
     <pc:chgData name="Anthony (Tony) Wilhelm" userId="111808ec-cec1-4bb5-b99a-563afe69ab96" providerId="ADAL" clId="{72BD8168-86F3-43FC-B709-0507F7810D7D}"/>
     <pc:docChg chg="undo custSel addSld delSld modSld sldOrd delMainMaster">
-      <pc:chgData name="Anthony (Tony) Wilhelm" userId="111808ec-cec1-4bb5-b99a-563afe69ab96" providerId="ADAL" clId="{72BD8168-86F3-43FC-B709-0507F7810D7D}" dt="2026-05-23T01:35:04.656" v="280" actId="1076"/>
+      <pc:chgData name="Anthony (Tony) Wilhelm" userId="111808ec-cec1-4bb5-b99a-563afe69ab96" providerId="ADAL" clId="{72BD8168-86F3-43FC-B709-0507F7810D7D}" dt="2026-07-18T11:32:57.581" v="294" actId="1076"/>
       <pc:docMkLst>
         <pc:docMk/>
       </pc:docMkLst>
-      <pc:sldChg chg="addSp modSp mod">
-        <pc:chgData name="Anthony (Tony) Wilhelm" userId="111808ec-cec1-4bb5-b99a-563afe69ab96" providerId="ADAL" clId="{72BD8168-86F3-43FC-B709-0507F7810D7D}" dt="2026-05-23T01:35:04.656" v="280" actId="1076"/>
+      <pc:sldChg chg="add ord setBg">
+        <pc:chgData name="Anthony (Tony) Wilhelm" userId="111808ec-cec1-4bb5-b99a-563afe69ab96" providerId="ADAL" clId="{72BD8168-86F3-43FC-B709-0507F7810D7D}" dt="2026-07-18T11:31:10.675" v="283"/>
         <pc:sldMkLst>
           <pc:docMk/>
-          <pc:sldMk cId="0" sldId="263"/>
+          <pc:sldMk cId="0" sldId="257"/>
         </pc:sldMkLst>
-        <pc:spChg chg="mod">
-          <ac:chgData name="Anthony (Tony) Wilhelm" userId="111808ec-cec1-4bb5-b99a-563afe69ab96" providerId="ADAL" clId="{72BD8168-86F3-43FC-B709-0507F7810D7D}" dt="2026-05-20T21:12:15.774" v="240" actId="1076"/>
-          <ac:spMkLst>
-            <pc:docMk/>
-            <pc:sldMk cId="0" sldId="263"/>
-            <ac:spMk id="140" creationId="{00000000-0000-0000-0000-000000000000}"/>
-          </ac:spMkLst>
-        </pc:spChg>
+      </pc:sldChg>
+      <pc:sldChg chg="addSp modSp add mod">
+        <pc:chgData name="Anthony (Tony) Wilhelm" userId="111808ec-cec1-4bb5-b99a-563afe69ab96" providerId="ADAL" clId="{72BD8168-86F3-43FC-B709-0507F7810D7D}" dt="2026-07-18T11:32:57.581" v="294" actId="1076"/>
+        <pc:sldMkLst>
+          <pc:docMk/>
+          <pc:sldMk cId="0" sldId="259"/>
+        </pc:sldMkLst>
         <pc:picChg chg="add mod">
-          <ac:chgData name="Anthony (Tony) Wilhelm" userId="111808ec-cec1-4bb5-b99a-563afe69ab96" providerId="ADAL" clId="{72BD8168-86F3-43FC-B709-0507F7810D7D}" dt="2026-05-23T01:34:58.614" v="279" actId="1076"/>
+          <ac:chgData name="Anthony (Tony) Wilhelm" userId="111808ec-cec1-4bb5-b99a-563afe69ab96" providerId="ADAL" clId="{72BD8168-86F3-43FC-B709-0507F7810D7D}" dt="2026-07-18T11:32:57.581" v="294" actId="1076"/>
           <ac:picMkLst>
             <pc:docMk/>
-            <pc:sldMk cId="0" sldId="263"/>
-            <ac:picMk id="3" creationId="{231BA57F-A3D9-C256-0007-A0C9EB442804}"/>
+            <pc:sldMk cId="0" sldId="259"/>
+            <ac:picMk id="7" creationId="{5B0281E3-6F40-4217-C280-DECB9E35DFFC}"/>
           </ac:picMkLst>
         </pc:picChg>
-        <pc:picChg chg="mod">
-          <ac:chgData name="Anthony (Tony) Wilhelm" userId="111808ec-cec1-4bb5-b99a-563afe69ab96" providerId="ADAL" clId="{72BD8168-86F3-43FC-B709-0507F7810D7D}" dt="2026-05-23T01:35:04.656" v="280" actId="1076"/>
-          <ac:picMkLst>
-            <pc:docMk/>
-            <pc:sldMk cId="0" sldId="263"/>
-            <ac:picMk id="141" creationId="{00000000-0000-0000-0000-000000000000}"/>
-          </ac:picMkLst>
-        </pc:picChg>
-        <pc:picChg chg="mod">
-          <ac:chgData name="Anthony (Tony) Wilhelm" userId="111808ec-cec1-4bb5-b99a-563afe69ab96" providerId="ADAL" clId="{72BD8168-86F3-43FC-B709-0507F7810D7D}" dt="2026-05-20T21:12:15.774" v="240" actId="1076"/>
-          <ac:picMkLst>
-            <pc:docMk/>
-            <pc:sldMk cId="0" sldId="263"/>
-            <ac:picMk id="1026" creationId="{77A8FF47-810A-F7F2-B2E9-AFB6E362A2BC}"/>
-          </ac:picMkLst>
-        </pc:picChg>
-        <pc:picChg chg="mod">
-          <ac:chgData name="Anthony (Tony) Wilhelm" userId="111808ec-cec1-4bb5-b99a-563afe69ab96" providerId="ADAL" clId="{72BD8168-86F3-43FC-B709-0507F7810D7D}" dt="2026-05-20T21:12:15.774" v="240" actId="1076"/>
-          <ac:picMkLst>
-            <pc:docMk/>
-            <pc:sldMk cId="0" sldId="263"/>
-            <ac:picMk id="1030" creationId="{7C9BD6B7-44DA-5C3C-E60A-E46FD371FB12}"/>
-          </ac:picMkLst>
-        </pc:picChg>
-        <pc:picChg chg="mod">
-          <ac:chgData name="Anthony (Tony) Wilhelm" userId="111808ec-cec1-4bb5-b99a-563afe69ab96" providerId="ADAL" clId="{72BD8168-86F3-43FC-B709-0507F7810D7D}" dt="2026-05-20T21:12:15.774" v="240" actId="1076"/>
-          <ac:picMkLst>
-            <pc:docMk/>
-            <pc:sldMk cId="0" sldId="263"/>
-            <ac:picMk id="1032" creationId="{BF886A15-8696-37A6-4205-45F2E8AB5658}"/>
-          </ac:picMkLst>
-        </pc:picChg>
-      </pc:sldChg>
-      <pc:sldChg chg="modSp mod">
-        <pc:chgData name="Anthony (Tony) Wilhelm" userId="111808ec-cec1-4bb5-b99a-563afe69ab96" providerId="ADAL" clId="{72BD8168-86F3-43FC-B709-0507F7810D7D}" dt="2026-05-13T16:23:05.840" v="175" actId="20577"/>
-        <pc:sldMkLst>
-          <pc:docMk/>
-          <pc:sldMk cId="0" sldId="265"/>
-        </pc:sldMkLst>
-        <pc:spChg chg="mod">
-          <ac:chgData name="Anthony (Tony) Wilhelm" userId="111808ec-cec1-4bb5-b99a-563afe69ab96" providerId="ADAL" clId="{72BD8168-86F3-43FC-B709-0507F7810D7D}" dt="2026-05-13T16:23:05.840" v="175" actId="20577"/>
-          <ac:spMkLst>
-            <pc:docMk/>
-            <pc:sldMk cId="0" sldId="265"/>
-            <ac:spMk id="165" creationId="{00000000-0000-0000-0000-000000000000}"/>
-          </ac:spMkLst>
-        </pc:spChg>
-      </pc:sldChg>
-      <pc:sldChg chg="modSp mod">
-        <pc:chgData name="Anthony (Tony) Wilhelm" userId="111808ec-cec1-4bb5-b99a-563afe69ab96" providerId="ADAL" clId="{72BD8168-86F3-43FC-B709-0507F7810D7D}" dt="2026-05-13T16:24:28.268" v="231" actId="20577"/>
-        <pc:sldMkLst>
-          <pc:docMk/>
-          <pc:sldMk cId="0" sldId="266"/>
-        </pc:sldMkLst>
-        <pc:spChg chg="mod">
-          <ac:chgData name="Anthony (Tony) Wilhelm" userId="111808ec-cec1-4bb5-b99a-563afe69ab96" providerId="ADAL" clId="{72BD8168-86F3-43FC-B709-0507F7810D7D}" dt="2026-05-13T16:24:28.268" v="231" actId="20577"/>
-          <ac:spMkLst>
-            <pc:docMk/>
-            <pc:sldMk cId="0" sldId="266"/>
-            <ac:spMk id="176" creationId="{00000000-0000-0000-0000-000000000000}"/>
-          </ac:spMkLst>
-        </pc:spChg>
-      </pc:sldChg>
-      <pc:sldChg chg="modSp mod">
-        <pc:chgData name="Anthony (Tony) Wilhelm" userId="111808ec-cec1-4bb5-b99a-563afe69ab96" providerId="ADAL" clId="{72BD8168-86F3-43FC-B709-0507F7810D7D}" dt="2026-05-13T16:22:14.022" v="161" actId="400"/>
-        <pc:sldMkLst>
-          <pc:docMk/>
-          <pc:sldMk cId="0" sldId="272"/>
-        </pc:sldMkLst>
-        <pc:spChg chg="mod">
-          <ac:chgData name="Anthony (Tony) Wilhelm" userId="111808ec-cec1-4bb5-b99a-563afe69ab96" providerId="ADAL" clId="{72BD8168-86F3-43FC-B709-0507F7810D7D}" dt="2026-05-13T16:22:14.022" v="161" actId="400"/>
-          <ac:spMkLst>
-            <pc:docMk/>
-            <pc:sldMk cId="0" sldId="272"/>
-            <ac:spMk id="262" creationId="{00000000-0000-0000-0000-000000000000}"/>
-          </ac:spMkLst>
-        </pc:spChg>
-      </pc:sldChg>
-      <pc:sldChg chg="modSp mod">
-        <pc:chgData name="Anthony (Tony) Wilhelm" userId="111808ec-cec1-4bb5-b99a-563afe69ab96" providerId="ADAL" clId="{72BD8168-86F3-43FC-B709-0507F7810D7D}" dt="2026-05-20T21:13:14.950" v="269" actId="108"/>
-        <pc:sldMkLst>
-          <pc:docMk/>
-          <pc:sldMk cId="0" sldId="284"/>
-        </pc:sldMkLst>
-        <pc:spChg chg="mod">
-          <ac:chgData name="Anthony (Tony) Wilhelm" userId="111808ec-cec1-4bb5-b99a-563afe69ab96" providerId="ADAL" clId="{72BD8168-86F3-43FC-B709-0507F7810D7D}" dt="2026-05-20T21:13:14.950" v="269" actId="108"/>
-          <ac:spMkLst>
-            <pc:docMk/>
-            <pc:sldMk cId="0" sldId="284"/>
-            <ac:spMk id="384" creationId="{00000000-0000-0000-0000-000000000000}"/>
-          </ac:spMkLst>
-        </pc:spChg>
       </pc:sldChg>
     </pc:docChg>
   </pc:docChgLst>
@@ -2083,7 +2005,7 @@
             </a:pPr>
             <a:fld id="{00000000-1234-1234-1234-123412341234}" type="slidenum">
               <a:rPr lang="en-US"/>
-              <a:t>11</a:t>
+              <a:t>12</a:t>
             </a:fld>
             <a:endParaRPr/>
           </a:p>
@@ -2254,7 +2176,7 @@
             </a:pPr>
             <a:fld id="{00000000-1234-1234-1234-123412341234}" type="slidenum">
               <a:rPr lang="en-US"/>
-              <a:t>12</a:t>
+              <a:t>13</a:t>
             </a:fld>
             <a:endParaRPr/>
           </a:p>
@@ -2425,7 +2347,7 @@
             </a:pPr>
             <a:fld id="{00000000-1234-1234-1234-123412341234}" type="slidenum">
               <a:rPr lang="en-US"/>
-              <a:t>13</a:t>
+              <a:t>14</a:t>
             </a:fld>
             <a:endParaRPr/>
           </a:p>
@@ -2929,7 +2851,7 @@
             </a:pPr>
             <a:fld id="{00000000-1234-1234-1234-123412341234}" type="slidenum">
               <a:rPr lang="en-US"/>
-              <a:t>17</a:t>
+              <a:t>18</a:t>
             </a:fld>
             <a:endParaRPr/>
           </a:p>
@@ -3211,7 +3133,7 @@
             </a:pPr>
             <a:fld id="{00000000-1234-1234-1234-123412341234}" type="slidenum">
               <a:rPr lang="en-US"/>
-              <a:t>19</a:t>
+              <a:t>20</a:t>
             </a:fld>
             <a:endParaRPr/>
           </a:p>
@@ -3604,7 +3526,7 @@
             </a:pPr>
             <a:fld id="{00000000-1234-1234-1234-123412341234}" type="slidenum">
               <a:rPr lang="en-US"/>
-              <a:t>21</a:t>
+              <a:t>22</a:t>
             </a:fld>
             <a:endParaRPr/>
           </a:p>
@@ -3775,7 +3697,7 @@
             </a:pPr>
             <a:fld id="{00000000-1234-1234-1234-123412341234}" type="slidenum">
               <a:rPr lang="en-US"/>
-              <a:t>22</a:t>
+              <a:t>23</a:t>
             </a:fld>
             <a:endParaRPr/>
           </a:p>
@@ -3946,7 +3868,7 @@
             </a:pPr>
             <a:fld id="{00000000-1234-1234-1234-123412341234}" type="slidenum">
               <a:rPr lang="en-US"/>
-              <a:t>23</a:t>
+              <a:t>24</a:t>
             </a:fld>
             <a:endParaRPr/>
           </a:p>
@@ -4117,7 +4039,7 @@
             </a:pPr>
             <a:fld id="{00000000-1234-1234-1234-123412341234}" type="slidenum">
               <a:rPr lang="en-US"/>
-              <a:t>24</a:t>
+              <a:t>25</a:t>
             </a:fld>
             <a:endParaRPr/>
           </a:p>
@@ -4293,7 +4215,7 @@
             </a:pPr>
             <a:fld id="{00000000-1234-1234-1234-123412341234}" type="slidenum">
               <a:rPr lang="en-US"/>
-              <a:t>3</a:t>
+              <a:t>4</a:t>
             </a:fld>
             <a:endParaRPr/>
           </a:p>
@@ -4468,7 +4390,7 @@
             </a:pPr>
             <a:fld id="{00000000-1234-1234-1234-123412341234}" type="slidenum">
               <a:rPr lang="en-US"/>
-              <a:t>4</a:t>
+              <a:t>5</a:t>
             </a:fld>
             <a:endParaRPr/>
           </a:p>
@@ -4643,7 +4565,7 @@
             </a:pPr>
             <a:fld id="{00000000-1234-1234-1234-123412341234}" type="slidenum">
               <a:rPr lang="en-US"/>
-              <a:t>5</a:t>
+              <a:t>6</a:t>
             </a:fld>
             <a:endParaRPr/>
           </a:p>
@@ -4814,7 +4736,7 @@
             </a:pPr>
             <a:fld id="{00000000-1234-1234-1234-123412341234}" type="slidenum">
               <a:rPr lang="en-US"/>
-              <a:t>6</a:t>
+              <a:t>7</a:t>
             </a:fld>
             <a:endParaRPr/>
           </a:p>
@@ -5207,7 +5129,7 @@
             </a:pPr>
             <a:fld id="{00000000-1234-1234-1234-123412341234}" type="slidenum">
               <a:rPr lang="en-US"/>
-              <a:t>9</a:t>
+              <a:t>10</a:t>
             </a:fld>
             <a:endParaRPr/>
           </a:p>
@@ -15860,6 +15782,460 @@
     </p:bg>
     <p:spTree>
       <p:nvGrpSpPr>
+        <p:cNvPr id="1" name="Shape 237"/>
+        <p:cNvGrpSpPr/>
+        <p:nvPr/>
+      </p:nvGrpSpPr>
+      <p:grpSpPr>
+        <a:xfrm>
+          <a:off x="0" y="0"/>
+          <a:ext cx="0" cy="0"/>
+          <a:chOff x="0" y="0"/>
+          <a:chExt cx="0" cy="0"/>
+        </a:xfrm>
+      </p:grpSpPr>
+      <p:sp>
+        <p:nvSpPr>
+          <p:cNvPr id="238" name="Google Shape;238;p10"/>
+          <p:cNvSpPr/>
+          <p:nvPr/>
+        </p:nvSpPr>
+        <p:spPr>
+          <a:xfrm flipH="1">
+            <a:off x="-3" y="-1"/>
+            <a:ext cx="12192000" cy="1590600"/>
+          </a:xfrm>
+          <a:prstGeom prst="rect">
+            <a:avLst/>
+          </a:prstGeom>
+          <a:gradFill>
+            <a:gsLst>
+              <a:gs pos="0">
+                <a:srgbClr val="000000"/>
+              </a:gs>
+              <a:gs pos="100000">
+                <a:srgbClr val="2F5496"/>
+              </a:gs>
+            </a:gsLst>
+            <a:lin ang="8400134" scaled="0"/>
+          </a:gradFill>
+          <a:ln>
+            <a:noFill/>
+          </a:ln>
+        </p:spPr>
+        <p:txBody>
+          <a:bodyPr spcFirstLastPara="1" wrap="square" lIns="91425" tIns="45700" rIns="91425" bIns="45700" anchor="ctr" anchorCtr="0">
+            <a:noAutofit/>
+          </a:bodyPr>
+          <a:lstStyle/>
+          <a:p>
+            <a:pPr marL="0" marR="0" lvl="0" indent="0" algn="ctr" rtl="0">
+              <a:spcBef>
+                <a:spcPts val="0"/>
+              </a:spcBef>
+              <a:spcAft>
+                <a:spcPts val="0"/>
+              </a:spcAft>
+              <a:buNone/>
+            </a:pPr>
+            <a:endParaRPr sz="1800" b="0" i="0" u="none" strike="noStrike" cap="none">
+              <a:solidFill>
+                <a:schemeClr val="lt1"/>
+              </a:solidFill>
+              <a:latin typeface="Calibri"/>
+              <a:ea typeface="Calibri"/>
+              <a:cs typeface="Calibri"/>
+              <a:sym typeface="Calibri"/>
+            </a:endParaRPr>
+          </a:p>
+        </p:txBody>
+      </p:sp>
+      <p:sp>
+        <p:nvSpPr>
+          <p:cNvPr id="239" name="Google Shape;239;p10"/>
+          <p:cNvSpPr/>
+          <p:nvPr/>
+        </p:nvSpPr>
+        <p:spPr>
+          <a:xfrm rot="10800000" flipH="1">
+            <a:off x="-3" y="142"/>
+            <a:ext cx="8115300" cy="1590600"/>
+          </a:xfrm>
+          <a:prstGeom prst="rect">
+            <a:avLst/>
+          </a:prstGeom>
+          <a:gradFill>
+            <a:gsLst>
+              <a:gs pos="0">
+                <a:srgbClr val="4472C4">
+                  <a:alpha val="0"/>
+                </a:srgbClr>
+              </a:gs>
+              <a:gs pos="20000">
+                <a:srgbClr val="4472C4">
+                  <a:alpha val="0"/>
+                </a:srgbClr>
+              </a:gs>
+              <a:gs pos="100000">
+                <a:srgbClr val="1F3864">
+                  <a:alpha val="54901"/>
+                </a:srgbClr>
+              </a:gs>
+            </a:gsLst>
+            <a:lin ang="13800146" scaled="0"/>
+          </a:gradFill>
+          <a:ln>
+            <a:noFill/>
+          </a:ln>
+        </p:spPr>
+        <p:txBody>
+          <a:bodyPr spcFirstLastPara="1" wrap="square" lIns="91425" tIns="45700" rIns="91425" bIns="45700" anchor="ctr" anchorCtr="0">
+            <a:noAutofit/>
+          </a:bodyPr>
+          <a:lstStyle/>
+          <a:p>
+            <a:pPr marL="0" marR="0" lvl="0" indent="0" algn="ctr" rtl="0">
+              <a:spcBef>
+                <a:spcPts val="0"/>
+              </a:spcBef>
+              <a:spcAft>
+                <a:spcPts val="0"/>
+              </a:spcAft>
+              <a:buNone/>
+            </a:pPr>
+            <a:endParaRPr sz="1800" b="0" i="0" u="none" strike="noStrike" cap="none">
+              <a:solidFill>
+                <a:schemeClr val="lt1"/>
+              </a:solidFill>
+              <a:latin typeface="Calibri"/>
+              <a:ea typeface="Calibri"/>
+              <a:cs typeface="Calibri"/>
+              <a:sym typeface="Calibri"/>
+            </a:endParaRPr>
+          </a:p>
+        </p:txBody>
+      </p:sp>
+      <p:sp>
+        <p:nvSpPr>
+          <p:cNvPr id="240" name="Google Shape;240;p10"/>
+          <p:cNvSpPr txBox="1">
+            <a:spLocks noGrp="1"/>
+          </p:cNvSpPr>
+          <p:nvPr>
+            <p:ph type="title"/>
+          </p:nvPr>
+        </p:nvSpPr>
+        <p:spPr>
+          <a:xfrm>
+            <a:off x="1371597" y="348865"/>
+            <a:ext cx="10044000" cy="877800"/>
+          </a:xfrm>
+          <a:prstGeom prst="rect">
+            <a:avLst/>
+          </a:prstGeom>
+          <a:noFill/>
+          <a:ln>
+            <a:noFill/>
+          </a:ln>
+        </p:spPr>
+        <p:txBody>
+          <a:bodyPr spcFirstLastPara="1" wrap="square" lIns="91425" tIns="45700" rIns="91425" bIns="45700" anchor="ctr" anchorCtr="0">
+            <a:normAutofit/>
+          </a:bodyPr>
+          <a:lstStyle/>
+          <a:p>
+            <a:pPr marL="0" lvl="0" indent="0" algn="l" rtl="0">
+              <a:lnSpc>
+                <a:spcPct val="90000"/>
+              </a:lnSpc>
+              <a:spcBef>
+                <a:spcPts val="0"/>
+              </a:spcBef>
+              <a:spcAft>
+                <a:spcPts val="0"/>
+              </a:spcAft>
+              <a:buClr>
+                <a:srgbClr val="FFFFFF"/>
+              </a:buClr>
+              <a:buSzPts val="4000"/>
+              <a:buFont typeface="Calibri"/>
+              <a:buNone/>
+            </a:pPr>
+            <a:r>
+              <a:rPr lang="en-US" sz="4000">
+                <a:solidFill>
+                  <a:srgbClr val="FFFFFF"/>
+                </a:solidFill>
+                <a:latin typeface="Calibri"/>
+                <a:ea typeface="Calibri"/>
+                <a:cs typeface="Calibri"/>
+                <a:sym typeface="Calibri"/>
+              </a:rPr>
+              <a:t>Variables</a:t>
+            </a:r>
+            <a:endParaRPr/>
+          </a:p>
+        </p:txBody>
+      </p:sp>
+      <p:sp>
+        <p:nvSpPr>
+          <p:cNvPr id="241" name="Google Shape;241;p10"/>
+          <p:cNvSpPr txBox="1">
+            <a:spLocks noGrp="1"/>
+          </p:cNvSpPr>
+          <p:nvPr>
+            <p:ph type="body" idx="2"/>
+          </p:nvPr>
+        </p:nvSpPr>
+        <p:spPr>
+          <a:xfrm>
+            <a:off x="1166297" y="2112579"/>
+            <a:ext cx="4872919" cy="4089712"/>
+          </a:xfrm>
+          <a:prstGeom prst="rect">
+            <a:avLst/>
+          </a:prstGeom>
+          <a:noFill/>
+          <a:ln>
+            <a:noFill/>
+          </a:ln>
+        </p:spPr>
+        <p:txBody>
+          <a:bodyPr spcFirstLastPara="1" wrap="square" lIns="91425" tIns="45700" rIns="91425" bIns="45700" anchor="t" anchorCtr="0">
+            <a:normAutofit/>
+          </a:bodyPr>
+          <a:lstStyle/>
+          <a:p>
+            <a:pPr marL="212598" lvl="0" indent="-212343" algn="l" rtl="0">
+              <a:lnSpc>
+                <a:spcPct val="90000"/>
+              </a:lnSpc>
+              <a:spcBef>
+                <a:spcPts val="0"/>
+              </a:spcBef>
+              <a:spcAft>
+                <a:spcPts val="0"/>
+              </a:spcAft>
+              <a:buClr>
+                <a:schemeClr val="dk1"/>
+              </a:buClr>
+              <a:buSzPts val="2600"/>
+              <a:buChar char="•"/>
+            </a:pPr>
+            <a:r>
+              <a:rPr lang="en-US" sz="2600" dirty="0">
+                <a:solidFill>
+                  <a:schemeClr val="dk1"/>
+                </a:solidFill>
+                <a:latin typeface="Calibri"/>
+                <a:ea typeface="Calibri"/>
+                <a:cs typeface="Calibri"/>
+                <a:sym typeface="Calibri"/>
+              </a:rPr>
+              <a:t>Names start with a $</a:t>
+            </a:r>
+            <a:endParaRPr sz="2600" dirty="0"/>
+          </a:p>
+          <a:p>
+            <a:pPr marL="212598" lvl="0" indent="-212343" algn="l" rtl="0">
+              <a:lnSpc>
+                <a:spcPct val="90000"/>
+              </a:lnSpc>
+              <a:spcBef>
+                <a:spcPts val="930"/>
+              </a:spcBef>
+              <a:spcAft>
+                <a:spcPts val="0"/>
+              </a:spcAft>
+              <a:buClr>
+                <a:schemeClr val="dk1"/>
+              </a:buClr>
+              <a:buSzPts val="2600"/>
+              <a:buChar char="•"/>
+            </a:pPr>
+            <a:r>
+              <a:rPr lang="en-US" sz="2600" dirty="0">
+                <a:solidFill>
+                  <a:schemeClr val="dk1"/>
+                </a:solidFill>
+                <a:latin typeface="Calibri"/>
+                <a:ea typeface="Calibri"/>
+                <a:cs typeface="Calibri"/>
+                <a:sym typeface="Calibri"/>
+              </a:rPr>
+              <a:t>Names are not case sensitive</a:t>
+            </a:r>
+            <a:endParaRPr sz="2600" dirty="0"/>
+          </a:p>
+          <a:p>
+            <a:pPr marL="212598" lvl="0" indent="-212343" algn="l" rtl="0">
+              <a:lnSpc>
+                <a:spcPct val="90000"/>
+              </a:lnSpc>
+              <a:spcBef>
+                <a:spcPts val="930"/>
+              </a:spcBef>
+              <a:spcAft>
+                <a:spcPts val="0"/>
+              </a:spcAft>
+              <a:buClr>
+                <a:schemeClr val="dk1"/>
+              </a:buClr>
+              <a:buSzPts val="2600"/>
+              <a:buChar char="•"/>
+            </a:pPr>
+            <a:r>
+              <a:rPr lang="en-US" sz="2600" dirty="0">
+                <a:solidFill>
+                  <a:schemeClr val="dk1"/>
+                </a:solidFill>
+                <a:latin typeface="Calibri"/>
+                <a:ea typeface="Calibri"/>
+                <a:cs typeface="Calibri"/>
+                <a:sym typeface="Calibri"/>
+              </a:rPr>
+              <a:t>Can contain numbers and letters</a:t>
+            </a:r>
+            <a:endParaRPr sz="2600" dirty="0"/>
+          </a:p>
+          <a:p>
+            <a:pPr marL="212598" lvl="0" indent="-212343" algn="l" rtl="0">
+              <a:lnSpc>
+                <a:spcPct val="90000"/>
+              </a:lnSpc>
+              <a:spcBef>
+                <a:spcPts val="930"/>
+              </a:spcBef>
+              <a:spcAft>
+                <a:spcPts val="0"/>
+              </a:spcAft>
+              <a:buClr>
+                <a:schemeClr val="dk1"/>
+              </a:buClr>
+              <a:buSzPts val="2600"/>
+              <a:buChar char="•"/>
+            </a:pPr>
+            <a:r>
+              <a:rPr lang="en-US" sz="2600" dirty="0"/>
+              <a:t>Variables have multiple scopes:</a:t>
+            </a:r>
+            <a:endParaRPr sz="2600" dirty="0"/>
+          </a:p>
+          <a:p>
+            <a:pPr marL="669798" lvl="1" indent="-225298" algn="l" rtl="0">
+              <a:lnSpc>
+                <a:spcPct val="90000"/>
+              </a:lnSpc>
+              <a:spcBef>
+                <a:spcPts val="930"/>
+              </a:spcBef>
+              <a:spcAft>
+                <a:spcPts val="0"/>
+              </a:spcAft>
+              <a:buClr>
+                <a:schemeClr val="dk1"/>
+              </a:buClr>
+              <a:buSzPts val="2600"/>
+              <a:buChar char="•"/>
+            </a:pPr>
+            <a:r>
+              <a:rPr lang="en-US" sz="2600" dirty="0"/>
+              <a:t>Global</a:t>
+            </a:r>
+            <a:endParaRPr sz="2600" dirty="0"/>
+          </a:p>
+          <a:p>
+            <a:pPr marL="669798" lvl="1" indent="-225298" algn="l" rtl="0">
+              <a:lnSpc>
+                <a:spcPct val="90000"/>
+              </a:lnSpc>
+              <a:spcBef>
+                <a:spcPts val="930"/>
+              </a:spcBef>
+              <a:spcAft>
+                <a:spcPts val="0"/>
+              </a:spcAft>
+              <a:buClr>
+                <a:schemeClr val="dk1"/>
+              </a:buClr>
+              <a:buSzPts val="2600"/>
+              <a:buChar char="•"/>
+            </a:pPr>
+            <a:r>
+              <a:rPr lang="en-US" sz="2600" dirty="0"/>
+              <a:t>Local</a:t>
+            </a:r>
+            <a:endParaRPr sz="2600" dirty="0"/>
+          </a:p>
+          <a:p>
+            <a:pPr marL="669798" lvl="1" indent="-225298" algn="l" rtl="0">
+              <a:lnSpc>
+                <a:spcPct val="90000"/>
+              </a:lnSpc>
+              <a:spcBef>
+                <a:spcPts val="930"/>
+              </a:spcBef>
+              <a:spcAft>
+                <a:spcPts val="0"/>
+              </a:spcAft>
+              <a:buClr>
+                <a:schemeClr val="dk1"/>
+              </a:buClr>
+              <a:buSzPts val="2600"/>
+              <a:buChar char="•"/>
+            </a:pPr>
+            <a:r>
+              <a:rPr lang="en-US" sz="2600" dirty="0"/>
+              <a:t>Script</a:t>
+            </a:r>
+            <a:endParaRPr sz="2600" dirty="0"/>
+          </a:p>
+          <a:p>
+            <a:pPr marL="669798" lvl="1" indent="-225298" algn="l" rtl="0">
+              <a:lnSpc>
+                <a:spcPct val="90000"/>
+              </a:lnSpc>
+              <a:spcBef>
+                <a:spcPts val="930"/>
+              </a:spcBef>
+              <a:spcAft>
+                <a:spcPts val="0"/>
+              </a:spcAft>
+              <a:buClr>
+                <a:schemeClr val="dk1"/>
+              </a:buClr>
+              <a:buSzPts val="2600"/>
+              <a:buChar char="•"/>
+            </a:pPr>
+            <a:r>
+              <a:rPr lang="en-US" sz="2600" dirty="0"/>
+              <a:t>Private (not really a scope)</a:t>
+            </a:r>
+            <a:endParaRPr sz="2600" dirty="0"/>
+          </a:p>
+        </p:txBody>
+      </p:sp>
+    </p:spTree>
+  </p:cSld>
+  <p:clrMapOvr>
+    <a:masterClrMapping/>
+  </p:clrMapOvr>
+</p:sld>
+</file>
+
+<file path=ppt/slides/slide11.xml><?xml version="1.0" encoding="utf-8"?>
+<p:sld xmlns:a="http://schemas.openxmlformats.org/drawingml/2006/main" xmlns:r="http://schemas.openxmlformats.org/officeDocument/2006/relationships" xmlns:p="http://schemas.openxmlformats.org/presentationml/2006/main">
+  <p:cSld>
+    <p:bg>
+      <p:bgPr>
+        <a:solidFill>
+          <a:schemeClr val="lt1"/>
+        </a:solidFill>
+        <a:effectLst/>
+      </p:bgPr>
+    </p:bg>
+    <p:spTree>
+      <p:nvGrpSpPr>
         <p:cNvPr id="1" name="Shape 245"/>
         <p:cNvGrpSpPr/>
         <p:nvPr/>
@@ -16285,7 +16661,7 @@
 </p:sld>
 </file>
 
-<file path=ppt/slides/slide11.xml><?xml version="1.0" encoding="utf-8"?>
+<file path=ppt/slides/slide12.xml><?xml version="1.0" encoding="utf-8"?>
 <p:sld xmlns:a="http://schemas.openxmlformats.org/drawingml/2006/main" xmlns:r="http://schemas.openxmlformats.org/officeDocument/2006/relationships" xmlns:p="http://schemas.openxmlformats.org/presentationml/2006/main">
   <p:cSld>
     <p:bg>
@@ -16946,7 +17322,7 @@
 </p:sld>
 </file>
 
-<file path=ppt/slides/slide12.xml><?xml version="1.0" encoding="utf-8"?>
+<file path=ppt/slides/slide13.xml><?xml version="1.0" encoding="utf-8"?>
 <p:sld xmlns:a="http://schemas.openxmlformats.org/drawingml/2006/main" xmlns:r="http://schemas.openxmlformats.org/officeDocument/2006/relationships" xmlns:p="http://schemas.openxmlformats.org/presentationml/2006/main">
   <p:cSld>
     <p:bg>
@@ -17647,7 +18023,7 @@
 </p:sld>
 </file>
 
-<file path=ppt/slides/slide13.xml><?xml version="1.0" encoding="utf-8"?>
+<file path=ppt/slides/slide14.xml><?xml version="1.0" encoding="utf-8"?>
 <p:sld xmlns:a="http://schemas.openxmlformats.org/drawingml/2006/main" xmlns:r="http://schemas.openxmlformats.org/officeDocument/2006/relationships" xmlns:p="http://schemas.openxmlformats.org/presentationml/2006/main">
   <p:cSld>
     <p:bg>
@@ -18065,7 +18441,7 @@
 </p:sld>
 </file>
 
-<file path=ppt/slides/slide14.xml><?xml version="1.0" encoding="utf-8"?>
+<file path=ppt/slides/slide15.xml><?xml version="1.0" encoding="utf-8"?>
 <p:sld xmlns:a="http://schemas.openxmlformats.org/drawingml/2006/main" xmlns:r="http://schemas.openxmlformats.org/officeDocument/2006/relationships" xmlns:p="http://schemas.openxmlformats.org/presentationml/2006/main">
   <p:cSld>
     <p:bg>
@@ -18495,7 +18871,7 @@
 </p:sld>
 </file>
 
-<file path=ppt/slides/slide15.xml><?xml version="1.0" encoding="utf-8"?>
+<file path=ppt/slides/slide16.xml><?xml version="1.0" encoding="utf-8"?>
 <p:sld xmlns:a="http://schemas.openxmlformats.org/drawingml/2006/main" xmlns:r="http://schemas.openxmlformats.org/officeDocument/2006/relationships" xmlns:p="http://schemas.openxmlformats.org/presentationml/2006/main">
   <p:cSld>
     <p:bg>
@@ -18935,7 +19311,7 @@
 </p:sld>
 </file>
 
-<file path=ppt/slides/slide16.xml><?xml version="1.0" encoding="utf-8"?>
+<file path=ppt/slides/slide17.xml><?xml version="1.0" encoding="utf-8"?>
 <p:sld xmlns:a="http://schemas.openxmlformats.org/drawingml/2006/main" xmlns:r="http://schemas.openxmlformats.org/officeDocument/2006/relationships" xmlns:p="http://schemas.openxmlformats.org/presentationml/2006/main">
   <p:cSld>
     <p:bg>
@@ -19288,7 +19664,7 @@
 </p:sld>
 </file>
 
-<file path=ppt/slides/slide17.xml><?xml version="1.0" encoding="utf-8"?>
+<file path=ppt/slides/slide18.xml><?xml version="1.0" encoding="utf-8"?>
 <p:sld xmlns:a="http://schemas.openxmlformats.org/drawingml/2006/main" xmlns:r="http://schemas.openxmlformats.org/officeDocument/2006/relationships" xmlns:p="http://schemas.openxmlformats.org/presentationml/2006/main">
   <p:cSld>
     <p:bg>
@@ -19685,7 +20061,7 @@
 </p:sld>
 </file>
 
-<file path=ppt/slides/slide18.xml><?xml version="1.0" encoding="utf-8"?>
+<file path=ppt/slides/slide19.xml><?xml version="1.0" encoding="utf-8"?>
 <p:sld xmlns:a="http://schemas.openxmlformats.org/drawingml/2006/main" xmlns:r="http://schemas.openxmlformats.org/officeDocument/2006/relationships" xmlns:p="http://schemas.openxmlformats.org/presentationml/2006/main">
   <p:cSld>
     <p:bg>
@@ -20039,423 +20415,6 @@
             <a:r>
               <a:rPr lang="en-US" sz="2600"/>
               <a:t>Select-Object</a:t>
-            </a:r>
-            <a:endParaRPr sz="2600"/>
-          </a:p>
-        </p:txBody>
-      </p:sp>
-    </p:spTree>
-  </p:cSld>
-  <p:clrMapOvr>
-    <a:masterClrMapping/>
-  </p:clrMapOvr>
-</p:sld>
-</file>
-
-<file path=ppt/slides/slide19.xml><?xml version="1.0" encoding="utf-8"?>
-<p:sld xmlns:a="http://schemas.openxmlformats.org/drawingml/2006/main" xmlns:r="http://schemas.openxmlformats.org/officeDocument/2006/relationships" xmlns:p="http://schemas.openxmlformats.org/presentationml/2006/main">
-  <p:cSld>
-    <p:bg>
-      <p:bgPr>
-        <a:solidFill>
-          <a:schemeClr val="lt1"/>
-        </a:solidFill>
-        <a:effectLst/>
-      </p:bgPr>
-    </p:bg>
-    <p:spTree>
-      <p:nvGrpSpPr>
-        <p:cNvPr id="1" name="Shape 338"/>
-        <p:cNvGrpSpPr/>
-        <p:nvPr/>
-      </p:nvGrpSpPr>
-      <p:grpSpPr>
-        <a:xfrm>
-          <a:off x="0" y="0"/>
-          <a:ext cx="0" cy="0"/>
-          <a:chOff x="0" y="0"/>
-          <a:chExt cx="0" cy="0"/>
-        </a:xfrm>
-      </p:grpSpPr>
-      <p:sp>
-        <p:nvSpPr>
-          <p:cNvPr id="339" name="Google Shape;339;g212d64ab2ef_1_34"/>
-          <p:cNvSpPr/>
-          <p:nvPr/>
-        </p:nvSpPr>
-        <p:spPr>
-          <a:xfrm>
-            <a:off x="0" y="0"/>
-            <a:ext cx="12192000" cy="6858000"/>
-          </a:xfrm>
-          <a:prstGeom prst="rect">
-            <a:avLst/>
-          </a:prstGeom>
-          <a:solidFill>
-            <a:schemeClr val="lt1"/>
-          </a:solidFill>
-          <a:ln>
-            <a:noFill/>
-          </a:ln>
-        </p:spPr>
-        <p:txBody>
-          <a:bodyPr spcFirstLastPara="1" wrap="square" lIns="91425" tIns="45700" rIns="91425" bIns="45700" anchor="ctr" anchorCtr="0">
-            <a:noAutofit/>
-          </a:bodyPr>
-          <a:lstStyle/>
-          <a:p>
-            <a:pPr marL="0" marR="0" lvl="0" indent="0" algn="ctr" rtl="0">
-              <a:spcBef>
-                <a:spcPts val="0"/>
-              </a:spcBef>
-              <a:spcAft>
-                <a:spcPts val="0"/>
-              </a:spcAft>
-              <a:buNone/>
-            </a:pPr>
-            <a:endParaRPr sz="1800" b="0" i="0" u="none" strike="noStrike" cap="none">
-              <a:solidFill>
-                <a:schemeClr val="lt1"/>
-              </a:solidFill>
-              <a:latin typeface="Calibri"/>
-              <a:ea typeface="Calibri"/>
-              <a:cs typeface="Calibri"/>
-              <a:sym typeface="Calibri"/>
-            </a:endParaRPr>
-          </a:p>
-        </p:txBody>
-      </p:sp>
-      <p:sp>
-        <p:nvSpPr>
-          <p:cNvPr id="340" name="Google Shape;340;g212d64ab2ef_1_34"/>
-          <p:cNvSpPr/>
-          <p:nvPr/>
-        </p:nvSpPr>
-        <p:spPr>
-          <a:xfrm flipH="1">
-            <a:off x="-3" y="-1"/>
-            <a:ext cx="12192000" cy="1590600"/>
-          </a:xfrm>
-          <a:prstGeom prst="rect">
-            <a:avLst/>
-          </a:prstGeom>
-          <a:gradFill>
-            <a:gsLst>
-              <a:gs pos="0">
-                <a:srgbClr val="000000"/>
-              </a:gs>
-              <a:gs pos="100000">
-                <a:srgbClr val="2F5496"/>
-              </a:gs>
-            </a:gsLst>
-            <a:lin ang="8400134" scaled="0"/>
-          </a:gradFill>
-          <a:ln>
-            <a:noFill/>
-          </a:ln>
-        </p:spPr>
-        <p:txBody>
-          <a:bodyPr spcFirstLastPara="1" wrap="square" lIns="91425" tIns="45700" rIns="91425" bIns="45700" anchor="ctr" anchorCtr="0">
-            <a:noAutofit/>
-          </a:bodyPr>
-          <a:lstStyle/>
-          <a:p>
-            <a:pPr marL="0" marR="0" lvl="0" indent="0" algn="ctr" rtl="0">
-              <a:spcBef>
-                <a:spcPts val="0"/>
-              </a:spcBef>
-              <a:spcAft>
-                <a:spcPts val="0"/>
-              </a:spcAft>
-              <a:buNone/>
-            </a:pPr>
-            <a:endParaRPr sz="1800" b="0" i="0" u="none" strike="noStrike" cap="none">
-              <a:solidFill>
-                <a:schemeClr val="lt1"/>
-              </a:solidFill>
-              <a:latin typeface="Calibri"/>
-              <a:ea typeface="Calibri"/>
-              <a:cs typeface="Calibri"/>
-              <a:sym typeface="Calibri"/>
-            </a:endParaRPr>
-          </a:p>
-        </p:txBody>
-      </p:sp>
-      <p:sp>
-        <p:nvSpPr>
-          <p:cNvPr id="341" name="Google Shape;341;g212d64ab2ef_1_34"/>
-          <p:cNvSpPr/>
-          <p:nvPr/>
-        </p:nvSpPr>
-        <p:spPr>
-          <a:xfrm rot="10800000" flipH="1">
-            <a:off x="-3" y="142"/>
-            <a:ext cx="8115300" cy="1590600"/>
-          </a:xfrm>
-          <a:prstGeom prst="rect">
-            <a:avLst/>
-          </a:prstGeom>
-          <a:gradFill>
-            <a:gsLst>
-              <a:gs pos="0">
-                <a:srgbClr val="4472C4">
-                  <a:alpha val="0"/>
-                </a:srgbClr>
-              </a:gs>
-              <a:gs pos="20000">
-                <a:srgbClr val="4472C4">
-                  <a:alpha val="0"/>
-                </a:srgbClr>
-              </a:gs>
-              <a:gs pos="100000">
-                <a:srgbClr val="1F3864">
-                  <a:alpha val="54901"/>
-                </a:srgbClr>
-              </a:gs>
-            </a:gsLst>
-            <a:lin ang="13800146" scaled="0"/>
-          </a:gradFill>
-          <a:ln>
-            <a:noFill/>
-          </a:ln>
-        </p:spPr>
-        <p:txBody>
-          <a:bodyPr spcFirstLastPara="1" wrap="square" lIns="91425" tIns="45700" rIns="91425" bIns="45700" anchor="ctr" anchorCtr="0">
-            <a:noAutofit/>
-          </a:bodyPr>
-          <a:lstStyle/>
-          <a:p>
-            <a:pPr marL="0" marR="0" lvl="0" indent="0" algn="ctr" rtl="0">
-              <a:spcBef>
-                <a:spcPts val="0"/>
-              </a:spcBef>
-              <a:spcAft>
-                <a:spcPts val="0"/>
-              </a:spcAft>
-              <a:buNone/>
-            </a:pPr>
-            <a:endParaRPr sz="1800" b="0" i="0" u="none" strike="noStrike" cap="none">
-              <a:solidFill>
-                <a:schemeClr val="lt1"/>
-              </a:solidFill>
-              <a:latin typeface="Calibri"/>
-              <a:ea typeface="Calibri"/>
-              <a:cs typeface="Calibri"/>
-              <a:sym typeface="Calibri"/>
-            </a:endParaRPr>
-          </a:p>
-        </p:txBody>
-      </p:sp>
-      <p:sp>
-        <p:nvSpPr>
-          <p:cNvPr id="342" name="Google Shape;342;g212d64ab2ef_1_34"/>
-          <p:cNvSpPr txBox="1">
-            <a:spLocks noGrp="1"/>
-          </p:cNvSpPr>
-          <p:nvPr>
-            <p:ph type="title"/>
-          </p:nvPr>
-        </p:nvSpPr>
-        <p:spPr>
-          <a:xfrm>
-            <a:off x="1371599" y="294538"/>
-            <a:ext cx="9896100" cy="1033800"/>
-          </a:xfrm>
-          <a:prstGeom prst="rect">
-            <a:avLst/>
-          </a:prstGeom>
-          <a:noFill/>
-          <a:ln>
-            <a:noFill/>
-          </a:ln>
-        </p:spPr>
-        <p:txBody>
-          <a:bodyPr spcFirstLastPara="1" wrap="square" lIns="91425" tIns="45700" rIns="91425" bIns="45700" anchor="ctr" anchorCtr="0">
-            <a:normAutofit/>
-          </a:bodyPr>
-          <a:lstStyle/>
-          <a:p>
-            <a:pPr marL="0" lvl="0" indent="0" algn="l" rtl="0">
-              <a:lnSpc>
-                <a:spcPct val="90000"/>
-              </a:lnSpc>
-              <a:spcBef>
-                <a:spcPts val="0"/>
-              </a:spcBef>
-              <a:spcAft>
-                <a:spcPts val="0"/>
-              </a:spcAft>
-              <a:buClr>
-                <a:srgbClr val="FFFFFF"/>
-              </a:buClr>
-              <a:buSzPts val="4000"/>
-              <a:buFont typeface="Calibri"/>
-              <a:buNone/>
-            </a:pPr>
-            <a:r>
-              <a:rPr lang="en-US" sz="4000">
-                <a:solidFill>
-                  <a:srgbClr val="FFFFFF"/>
-                </a:solidFill>
-              </a:rPr>
-              <a:t>Formatting Output</a:t>
-            </a:r>
-            <a:endParaRPr/>
-          </a:p>
-        </p:txBody>
-      </p:sp>
-      <p:sp>
-        <p:nvSpPr>
-          <p:cNvPr id="343" name="Google Shape;343;g212d64ab2ef_1_34"/>
-          <p:cNvSpPr txBox="1">
-            <a:spLocks noGrp="1"/>
-          </p:cNvSpPr>
-          <p:nvPr>
-            <p:ph type="body" idx="1"/>
-          </p:nvPr>
-        </p:nvSpPr>
-        <p:spPr>
-          <a:xfrm>
-            <a:off x="1371599" y="2318197"/>
-            <a:ext cx="9723900" cy="3683400"/>
-          </a:xfrm>
-          <a:prstGeom prst="rect">
-            <a:avLst/>
-          </a:prstGeom>
-          <a:noFill/>
-          <a:ln>
-            <a:noFill/>
-          </a:ln>
-        </p:spPr>
-        <p:txBody>
-          <a:bodyPr spcFirstLastPara="1" wrap="square" lIns="91425" tIns="45700" rIns="91425" bIns="45700" anchor="ctr" anchorCtr="0">
-            <a:normAutofit/>
-          </a:bodyPr>
-          <a:lstStyle/>
-          <a:p>
-            <a:pPr marL="228600" lvl="0" indent="-101600" algn="l" rtl="0">
-              <a:lnSpc>
-                <a:spcPct val="90000"/>
-              </a:lnSpc>
-              <a:spcBef>
-                <a:spcPts val="0"/>
-              </a:spcBef>
-              <a:spcAft>
-                <a:spcPts val="0"/>
-              </a:spcAft>
-              <a:buClr>
-                <a:schemeClr val="dk1"/>
-              </a:buClr>
-              <a:buSzPts val="2000"/>
-              <a:buNone/>
-            </a:pPr>
-            <a:r>
-              <a:rPr lang="en-US" sz="2600"/>
-              <a:t>Multiple ways to format the output from a function</a:t>
-            </a:r>
-            <a:endParaRPr sz="2600"/>
-          </a:p>
-          <a:p>
-            <a:pPr marL="228600" lvl="0" indent="-101600" algn="l" rtl="0">
-              <a:lnSpc>
-                <a:spcPct val="90000"/>
-              </a:lnSpc>
-              <a:spcBef>
-                <a:spcPts val="0"/>
-              </a:spcBef>
-              <a:spcAft>
-                <a:spcPts val="0"/>
-              </a:spcAft>
-              <a:buClr>
-                <a:schemeClr val="dk1"/>
-              </a:buClr>
-              <a:buSzPts val="2000"/>
-              <a:buNone/>
-            </a:pPr>
-            <a:endParaRPr sz="2600"/>
-          </a:p>
-          <a:p>
-            <a:pPr marL="457200" lvl="0" indent="-393700" algn="l" rtl="0">
-              <a:spcBef>
-                <a:spcPts val="1000"/>
-              </a:spcBef>
-              <a:spcAft>
-                <a:spcPts val="0"/>
-              </a:spcAft>
-              <a:buSzPts val="2600"/>
-              <a:buChar char="●"/>
-            </a:pPr>
-            <a:r>
-              <a:rPr lang="en-US" sz="2600"/>
-              <a:t>Format-List</a:t>
-            </a:r>
-            <a:endParaRPr sz="2600"/>
-          </a:p>
-          <a:p>
-            <a:pPr marL="457200" lvl="0" indent="-393700" algn="l" rtl="0">
-              <a:spcBef>
-                <a:spcPts val="0"/>
-              </a:spcBef>
-              <a:spcAft>
-                <a:spcPts val="0"/>
-              </a:spcAft>
-              <a:buSzPts val="2600"/>
-              <a:buChar char="●"/>
-            </a:pPr>
-            <a:r>
-              <a:rPr lang="en-US" sz="2600"/>
-              <a:t>Format-Table</a:t>
-            </a:r>
-            <a:endParaRPr sz="2600"/>
-          </a:p>
-          <a:p>
-            <a:pPr marL="457200" lvl="0" indent="-393700" algn="l" rtl="0">
-              <a:spcBef>
-                <a:spcPts val="0"/>
-              </a:spcBef>
-              <a:spcAft>
-                <a:spcPts val="0"/>
-              </a:spcAft>
-              <a:buSzPts val="2600"/>
-              <a:buChar char="●"/>
-            </a:pPr>
-            <a:r>
-              <a:rPr lang="en-US" sz="2600"/>
-              <a:t>Out-Gridview</a:t>
-            </a:r>
-            <a:endParaRPr sz="2600"/>
-          </a:p>
-          <a:p>
-            <a:pPr marL="457200" lvl="0" indent="-393700" algn="l" rtl="0">
-              <a:spcBef>
-                <a:spcPts val="0"/>
-              </a:spcBef>
-              <a:spcAft>
-                <a:spcPts val="0"/>
-              </a:spcAft>
-              <a:buSzPts val="2600"/>
-              <a:buChar char="●"/>
-            </a:pPr>
-            <a:r>
-              <a:rPr lang="en-US" sz="2600"/>
-              <a:t>Write-Out</a:t>
-            </a:r>
-            <a:endParaRPr sz="2600"/>
-          </a:p>
-          <a:p>
-            <a:pPr marL="457200" lvl="0" indent="-393700" algn="l" rtl="0">
-              <a:spcBef>
-                <a:spcPts val="0"/>
-              </a:spcBef>
-              <a:spcAft>
-                <a:spcPts val="0"/>
-              </a:spcAft>
-              <a:buSzPts val="2600"/>
-              <a:buChar char="●"/>
-            </a:pPr>
-            <a:r>
-              <a:rPr lang="en-US" sz="2600"/>
-              <a:t>Write-Verbose</a:t>
             </a:r>
             <a:endParaRPr sz="2600"/>
           </a:p>
@@ -21105,7 +21064,7 @@
     </p:bg>
     <p:spTree>
       <p:nvGrpSpPr>
-        <p:cNvPr id="1" name="Shape 347"/>
+        <p:cNvPr id="1" name="Shape 338"/>
         <p:cNvGrpSpPr/>
         <p:nvPr/>
       </p:nvGrpSpPr>
@@ -21119,7 +21078,7 @@
       </p:grpSpPr>
       <p:sp>
         <p:nvSpPr>
-          <p:cNvPr id="348" name="Google Shape;348;p16"/>
+          <p:cNvPr id="339" name="Google Shape;339;g212d64ab2ef_1_34"/>
           <p:cNvSpPr/>
           <p:nvPr/>
         </p:nvSpPr>
@@ -21167,7 +21126,7 @@
       </p:sp>
       <p:sp>
         <p:nvSpPr>
-          <p:cNvPr id="349" name="Google Shape;349;p16"/>
+          <p:cNvPr id="340" name="Google Shape;340;g212d64ab2ef_1_34"/>
           <p:cNvSpPr/>
           <p:nvPr/>
         </p:nvSpPr>
@@ -21223,7 +21182,7 @@
       </p:sp>
       <p:sp>
         <p:nvSpPr>
-          <p:cNvPr id="350" name="Google Shape;350;p16"/>
+          <p:cNvPr id="341" name="Google Shape;341;g212d64ab2ef_1_34"/>
           <p:cNvSpPr/>
           <p:nvPr/>
         </p:nvSpPr>
@@ -21288,6 +21247,423 @@
       </p:sp>
       <p:sp>
         <p:nvSpPr>
+          <p:cNvPr id="342" name="Google Shape;342;g212d64ab2ef_1_34"/>
+          <p:cNvSpPr txBox="1">
+            <a:spLocks noGrp="1"/>
+          </p:cNvSpPr>
+          <p:nvPr>
+            <p:ph type="title"/>
+          </p:nvPr>
+        </p:nvSpPr>
+        <p:spPr>
+          <a:xfrm>
+            <a:off x="1371599" y="294538"/>
+            <a:ext cx="9896100" cy="1033800"/>
+          </a:xfrm>
+          <a:prstGeom prst="rect">
+            <a:avLst/>
+          </a:prstGeom>
+          <a:noFill/>
+          <a:ln>
+            <a:noFill/>
+          </a:ln>
+        </p:spPr>
+        <p:txBody>
+          <a:bodyPr spcFirstLastPara="1" wrap="square" lIns="91425" tIns="45700" rIns="91425" bIns="45700" anchor="ctr" anchorCtr="0">
+            <a:normAutofit/>
+          </a:bodyPr>
+          <a:lstStyle/>
+          <a:p>
+            <a:pPr marL="0" lvl="0" indent="0" algn="l" rtl="0">
+              <a:lnSpc>
+                <a:spcPct val="90000"/>
+              </a:lnSpc>
+              <a:spcBef>
+                <a:spcPts val="0"/>
+              </a:spcBef>
+              <a:spcAft>
+                <a:spcPts val="0"/>
+              </a:spcAft>
+              <a:buClr>
+                <a:srgbClr val="FFFFFF"/>
+              </a:buClr>
+              <a:buSzPts val="4000"/>
+              <a:buFont typeface="Calibri"/>
+              <a:buNone/>
+            </a:pPr>
+            <a:r>
+              <a:rPr lang="en-US" sz="4000">
+                <a:solidFill>
+                  <a:srgbClr val="FFFFFF"/>
+                </a:solidFill>
+              </a:rPr>
+              <a:t>Formatting Output</a:t>
+            </a:r>
+            <a:endParaRPr/>
+          </a:p>
+        </p:txBody>
+      </p:sp>
+      <p:sp>
+        <p:nvSpPr>
+          <p:cNvPr id="343" name="Google Shape;343;g212d64ab2ef_1_34"/>
+          <p:cNvSpPr txBox="1">
+            <a:spLocks noGrp="1"/>
+          </p:cNvSpPr>
+          <p:nvPr>
+            <p:ph type="body" idx="1"/>
+          </p:nvPr>
+        </p:nvSpPr>
+        <p:spPr>
+          <a:xfrm>
+            <a:off x="1371599" y="2318197"/>
+            <a:ext cx="9723900" cy="3683400"/>
+          </a:xfrm>
+          <a:prstGeom prst="rect">
+            <a:avLst/>
+          </a:prstGeom>
+          <a:noFill/>
+          <a:ln>
+            <a:noFill/>
+          </a:ln>
+        </p:spPr>
+        <p:txBody>
+          <a:bodyPr spcFirstLastPara="1" wrap="square" lIns="91425" tIns="45700" rIns="91425" bIns="45700" anchor="ctr" anchorCtr="0">
+            <a:normAutofit/>
+          </a:bodyPr>
+          <a:lstStyle/>
+          <a:p>
+            <a:pPr marL="228600" lvl="0" indent="-101600" algn="l" rtl="0">
+              <a:lnSpc>
+                <a:spcPct val="90000"/>
+              </a:lnSpc>
+              <a:spcBef>
+                <a:spcPts val="0"/>
+              </a:spcBef>
+              <a:spcAft>
+                <a:spcPts val="0"/>
+              </a:spcAft>
+              <a:buClr>
+                <a:schemeClr val="dk1"/>
+              </a:buClr>
+              <a:buSzPts val="2000"/>
+              <a:buNone/>
+            </a:pPr>
+            <a:r>
+              <a:rPr lang="en-US" sz="2600"/>
+              <a:t>Multiple ways to format the output from a function</a:t>
+            </a:r>
+            <a:endParaRPr sz="2600"/>
+          </a:p>
+          <a:p>
+            <a:pPr marL="228600" lvl="0" indent="-101600" algn="l" rtl="0">
+              <a:lnSpc>
+                <a:spcPct val="90000"/>
+              </a:lnSpc>
+              <a:spcBef>
+                <a:spcPts val="0"/>
+              </a:spcBef>
+              <a:spcAft>
+                <a:spcPts val="0"/>
+              </a:spcAft>
+              <a:buClr>
+                <a:schemeClr val="dk1"/>
+              </a:buClr>
+              <a:buSzPts val="2000"/>
+              <a:buNone/>
+            </a:pPr>
+            <a:endParaRPr sz="2600"/>
+          </a:p>
+          <a:p>
+            <a:pPr marL="457200" lvl="0" indent="-393700" algn="l" rtl="0">
+              <a:spcBef>
+                <a:spcPts val="1000"/>
+              </a:spcBef>
+              <a:spcAft>
+                <a:spcPts val="0"/>
+              </a:spcAft>
+              <a:buSzPts val="2600"/>
+              <a:buChar char="●"/>
+            </a:pPr>
+            <a:r>
+              <a:rPr lang="en-US" sz="2600"/>
+              <a:t>Format-List</a:t>
+            </a:r>
+            <a:endParaRPr sz="2600"/>
+          </a:p>
+          <a:p>
+            <a:pPr marL="457200" lvl="0" indent="-393700" algn="l" rtl="0">
+              <a:spcBef>
+                <a:spcPts val="0"/>
+              </a:spcBef>
+              <a:spcAft>
+                <a:spcPts val="0"/>
+              </a:spcAft>
+              <a:buSzPts val="2600"/>
+              <a:buChar char="●"/>
+            </a:pPr>
+            <a:r>
+              <a:rPr lang="en-US" sz="2600"/>
+              <a:t>Format-Table</a:t>
+            </a:r>
+            <a:endParaRPr sz="2600"/>
+          </a:p>
+          <a:p>
+            <a:pPr marL="457200" lvl="0" indent="-393700" algn="l" rtl="0">
+              <a:spcBef>
+                <a:spcPts val="0"/>
+              </a:spcBef>
+              <a:spcAft>
+                <a:spcPts val="0"/>
+              </a:spcAft>
+              <a:buSzPts val="2600"/>
+              <a:buChar char="●"/>
+            </a:pPr>
+            <a:r>
+              <a:rPr lang="en-US" sz="2600"/>
+              <a:t>Out-Gridview</a:t>
+            </a:r>
+            <a:endParaRPr sz="2600"/>
+          </a:p>
+          <a:p>
+            <a:pPr marL="457200" lvl="0" indent="-393700" algn="l" rtl="0">
+              <a:spcBef>
+                <a:spcPts val="0"/>
+              </a:spcBef>
+              <a:spcAft>
+                <a:spcPts val="0"/>
+              </a:spcAft>
+              <a:buSzPts val="2600"/>
+              <a:buChar char="●"/>
+            </a:pPr>
+            <a:r>
+              <a:rPr lang="en-US" sz="2600"/>
+              <a:t>Write-Out</a:t>
+            </a:r>
+            <a:endParaRPr sz="2600"/>
+          </a:p>
+          <a:p>
+            <a:pPr marL="457200" lvl="0" indent="-393700" algn="l" rtl="0">
+              <a:spcBef>
+                <a:spcPts val="0"/>
+              </a:spcBef>
+              <a:spcAft>
+                <a:spcPts val="0"/>
+              </a:spcAft>
+              <a:buSzPts val="2600"/>
+              <a:buChar char="●"/>
+            </a:pPr>
+            <a:r>
+              <a:rPr lang="en-US" sz="2600"/>
+              <a:t>Write-Verbose</a:t>
+            </a:r>
+            <a:endParaRPr sz="2600"/>
+          </a:p>
+        </p:txBody>
+      </p:sp>
+    </p:spTree>
+  </p:cSld>
+  <p:clrMapOvr>
+    <a:masterClrMapping/>
+  </p:clrMapOvr>
+</p:sld>
+</file>
+
+<file path=ppt/slides/slide21.xml><?xml version="1.0" encoding="utf-8"?>
+<p:sld xmlns:a="http://schemas.openxmlformats.org/drawingml/2006/main" xmlns:r="http://schemas.openxmlformats.org/officeDocument/2006/relationships" xmlns:p="http://schemas.openxmlformats.org/presentationml/2006/main">
+  <p:cSld>
+    <p:bg>
+      <p:bgPr>
+        <a:solidFill>
+          <a:schemeClr val="lt1"/>
+        </a:solidFill>
+        <a:effectLst/>
+      </p:bgPr>
+    </p:bg>
+    <p:spTree>
+      <p:nvGrpSpPr>
+        <p:cNvPr id="1" name="Shape 347"/>
+        <p:cNvGrpSpPr/>
+        <p:nvPr/>
+      </p:nvGrpSpPr>
+      <p:grpSpPr>
+        <a:xfrm>
+          <a:off x="0" y="0"/>
+          <a:ext cx="0" cy="0"/>
+          <a:chOff x="0" y="0"/>
+          <a:chExt cx="0" cy="0"/>
+        </a:xfrm>
+      </p:grpSpPr>
+      <p:sp>
+        <p:nvSpPr>
+          <p:cNvPr id="348" name="Google Shape;348;p16"/>
+          <p:cNvSpPr/>
+          <p:nvPr/>
+        </p:nvSpPr>
+        <p:spPr>
+          <a:xfrm>
+            <a:off x="0" y="0"/>
+            <a:ext cx="12192000" cy="6858000"/>
+          </a:xfrm>
+          <a:prstGeom prst="rect">
+            <a:avLst/>
+          </a:prstGeom>
+          <a:solidFill>
+            <a:schemeClr val="lt1"/>
+          </a:solidFill>
+          <a:ln>
+            <a:noFill/>
+          </a:ln>
+        </p:spPr>
+        <p:txBody>
+          <a:bodyPr spcFirstLastPara="1" wrap="square" lIns="91425" tIns="45700" rIns="91425" bIns="45700" anchor="ctr" anchorCtr="0">
+            <a:noAutofit/>
+          </a:bodyPr>
+          <a:lstStyle/>
+          <a:p>
+            <a:pPr marL="0" marR="0" lvl="0" indent="0" algn="ctr" rtl="0">
+              <a:spcBef>
+                <a:spcPts val="0"/>
+              </a:spcBef>
+              <a:spcAft>
+                <a:spcPts val="0"/>
+              </a:spcAft>
+              <a:buNone/>
+            </a:pPr>
+            <a:endParaRPr sz="1800" b="0" i="0" u="none" strike="noStrike" cap="none">
+              <a:solidFill>
+                <a:schemeClr val="lt1"/>
+              </a:solidFill>
+              <a:latin typeface="Calibri"/>
+              <a:ea typeface="Calibri"/>
+              <a:cs typeface="Calibri"/>
+              <a:sym typeface="Calibri"/>
+            </a:endParaRPr>
+          </a:p>
+        </p:txBody>
+      </p:sp>
+      <p:sp>
+        <p:nvSpPr>
+          <p:cNvPr id="349" name="Google Shape;349;p16"/>
+          <p:cNvSpPr/>
+          <p:nvPr/>
+        </p:nvSpPr>
+        <p:spPr>
+          <a:xfrm flipH="1">
+            <a:off x="-3" y="-1"/>
+            <a:ext cx="12192000" cy="1590600"/>
+          </a:xfrm>
+          <a:prstGeom prst="rect">
+            <a:avLst/>
+          </a:prstGeom>
+          <a:gradFill>
+            <a:gsLst>
+              <a:gs pos="0">
+                <a:srgbClr val="000000"/>
+              </a:gs>
+              <a:gs pos="100000">
+                <a:srgbClr val="2F5496"/>
+              </a:gs>
+            </a:gsLst>
+            <a:lin ang="8400134" scaled="0"/>
+          </a:gradFill>
+          <a:ln>
+            <a:noFill/>
+          </a:ln>
+        </p:spPr>
+        <p:txBody>
+          <a:bodyPr spcFirstLastPara="1" wrap="square" lIns="91425" tIns="45700" rIns="91425" bIns="45700" anchor="ctr" anchorCtr="0">
+            <a:noAutofit/>
+          </a:bodyPr>
+          <a:lstStyle/>
+          <a:p>
+            <a:pPr marL="0" marR="0" lvl="0" indent="0" algn="ctr" rtl="0">
+              <a:spcBef>
+                <a:spcPts val="0"/>
+              </a:spcBef>
+              <a:spcAft>
+                <a:spcPts val="0"/>
+              </a:spcAft>
+              <a:buNone/>
+            </a:pPr>
+            <a:endParaRPr sz="1800" b="0" i="0" u="none" strike="noStrike" cap="none">
+              <a:solidFill>
+                <a:schemeClr val="lt1"/>
+              </a:solidFill>
+              <a:latin typeface="Calibri"/>
+              <a:ea typeface="Calibri"/>
+              <a:cs typeface="Calibri"/>
+              <a:sym typeface="Calibri"/>
+            </a:endParaRPr>
+          </a:p>
+        </p:txBody>
+      </p:sp>
+      <p:sp>
+        <p:nvSpPr>
+          <p:cNvPr id="350" name="Google Shape;350;p16"/>
+          <p:cNvSpPr/>
+          <p:nvPr/>
+        </p:nvSpPr>
+        <p:spPr>
+          <a:xfrm rot="10800000" flipH="1">
+            <a:off x="-3" y="142"/>
+            <a:ext cx="8115300" cy="1590600"/>
+          </a:xfrm>
+          <a:prstGeom prst="rect">
+            <a:avLst/>
+          </a:prstGeom>
+          <a:gradFill>
+            <a:gsLst>
+              <a:gs pos="0">
+                <a:srgbClr val="4472C4">
+                  <a:alpha val="0"/>
+                </a:srgbClr>
+              </a:gs>
+              <a:gs pos="20000">
+                <a:srgbClr val="4472C4">
+                  <a:alpha val="0"/>
+                </a:srgbClr>
+              </a:gs>
+              <a:gs pos="100000">
+                <a:srgbClr val="1F3864">
+                  <a:alpha val="54901"/>
+                </a:srgbClr>
+              </a:gs>
+            </a:gsLst>
+            <a:lin ang="13800146" scaled="0"/>
+          </a:gradFill>
+          <a:ln>
+            <a:noFill/>
+          </a:ln>
+        </p:spPr>
+        <p:txBody>
+          <a:bodyPr spcFirstLastPara="1" wrap="square" lIns="91425" tIns="45700" rIns="91425" bIns="45700" anchor="ctr" anchorCtr="0">
+            <a:noAutofit/>
+          </a:bodyPr>
+          <a:lstStyle/>
+          <a:p>
+            <a:pPr marL="0" marR="0" lvl="0" indent="0" algn="ctr" rtl="0">
+              <a:spcBef>
+                <a:spcPts val="0"/>
+              </a:spcBef>
+              <a:spcAft>
+                <a:spcPts val="0"/>
+              </a:spcAft>
+              <a:buNone/>
+            </a:pPr>
+            <a:endParaRPr sz="1800" b="0" i="0" u="none" strike="noStrike" cap="none">
+              <a:solidFill>
+                <a:schemeClr val="lt1"/>
+              </a:solidFill>
+              <a:latin typeface="Calibri"/>
+              <a:ea typeface="Calibri"/>
+              <a:cs typeface="Calibri"/>
+              <a:sym typeface="Calibri"/>
+            </a:endParaRPr>
+          </a:p>
+        </p:txBody>
+      </p:sp>
+      <p:sp>
+        <p:nvSpPr>
           <p:cNvPr id="351" name="Google Shape;351;p16"/>
           <p:cNvSpPr txBox="1">
             <a:spLocks noGrp="1"/>
@@ -21527,7 +21903,7 @@
 </p:sld>
 </file>
 
-<file path=ppt/slides/slide21.xml><?xml version="1.0" encoding="utf-8"?>
+<file path=ppt/slides/slide22.xml><?xml version="1.0" encoding="utf-8"?>
 <p:sld xmlns:a="http://schemas.openxmlformats.org/drawingml/2006/main" xmlns:r="http://schemas.openxmlformats.org/officeDocument/2006/relationships" xmlns:p="http://schemas.openxmlformats.org/presentationml/2006/main">
   <p:cSld>
     <p:bg>
@@ -21993,7 +22369,7 @@
 </p:sld>
 </file>
 
-<file path=ppt/slides/slide22.xml><?xml version="1.0" encoding="utf-8"?>
+<file path=ppt/slides/slide23.xml><?xml version="1.0" encoding="utf-8"?>
 <p:sld xmlns:a="http://schemas.openxmlformats.org/drawingml/2006/main" xmlns:r="http://schemas.openxmlformats.org/officeDocument/2006/relationships" xmlns:p="http://schemas.openxmlformats.org/presentationml/2006/main">
   <p:cSld>
     <p:bg>
@@ -22651,7 +23027,7 @@
 </p:sld>
 </file>
 
-<file path=ppt/slides/slide23.xml><?xml version="1.0" encoding="utf-8"?>
+<file path=ppt/slides/slide24.xml><?xml version="1.0" encoding="utf-8"?>
 <p:sld xmlns:a="http://schemas.openxmlformats.org/drawingml/2006/main" xmlns:r="http://schemas.openxmlformats.org/officeDocument/2006/relationships" xmlns:p="http://schemas.openxmlformats.org/presentationml/2006/main">
   <p:cSld>
     <p:bg>
@@ -23224,7 +23600,7 @@
 </p:sld>
 </file>
 
-<file path=ppt/slides/slide24.xml><?xml version="1.0" encoding="utf-8"?>
+<file path=ppt/slides/slide25.xml><?xml version="1.0" encoding="utf-8"?>
 <p:sld xmlns:a="http://schemas.openxmlformats.org/drawingml/2006/main" xmlns:r="http://schemas.openxmlformats.org/officeDocument/2006/relationships" xmlns:p="http://schemas.openxmlformats.org/presentationml/2006/main">
   <p:cSld>
     <p:bg>
@@ -23552,7 +23928,950 @@
 </p:sld>
 </file>
 
+<file path=ppt/slides/slide26.xml><?xml version="1.0" encoding="utf-8"?>
+<p:sld xmlns:a="http://schemas.openxmlformats.org/drawingml/2006/main" xmlns:r="http://schemas.openxmlformats.org/officeDocument/2006/relationships" xmlns:p="http://schemas.openxmlformats.org/presentationml/2006/main">
+  <p:cSld>
+    <p:spTree>
+      <p:nvGrpSpPr>
+        <p:cNvPr id="1" name=""/>
+        <p:cNvGrpSpPr/>
+        <p:nvPr/>
+      </p:nvGrpSpPr>
+      <p:grpSpPr>
+        <a:xfrm>
+          <a:off x="0" y="0"/>
+          <a:ext cx="0" cy="0"/>
+          <a:chOff x="0" y="0"/>
+          <a:chExt cx="0" cy="0"/>
+        </a:xfrm>
+      </p:grpSpPr>
+      <p:sp>
+        <p:nvSpPr>
+          <p:cNvPr id="2" name="TextBox 1"/>
+          <p:cNvSpPr txBox="1"/>
+          <p:nvPr/>
+        </p:nvSpPr>
+        <p:spPr>
+          <a:xfrm>
+            <a:off x="841248" y="502920"/>
+            <a:ext cx="10515600" cy="795528"/>
+          </a:xfrm>
+          <a:prstGeom prst="rect">
+            <a:avLst/>
+          </a:prstGeom>
+          <a:noFill/>
+        </p:spPr>
+        <p:txBody>
+          <a:bodyPr wrap="square">
+            <a:spAutoFit/>
+          </a:bodyPr>
+          <a:lstStyle/>
+          <a:p>
+            <a:pPr algn="ctr"/>
+            <a:r>
+              <a:rPr sz="3200" b="1">
+                <a:solidFill>
+                  <a:srgbClr val="013169"/>
+                </a:solidFill>
+                <a:latin typeface="Berlin Sans FB"/>
+              </a:rPr>
+              <a:t>Please complete your session evaluations</a:t>
+            </a:r>
+          </a:p>
+        </p:txBody>
+      </p:sp>
+      <p:pic>
+        <p:nvPicPr>
+          <p:cNvPr id="3" name="Picture 2" descr="event-logo.png"/>
+          <p:cNvPicPr>
+            <a:picLocks noChangeAspect="1"/>
+          </p:cNvPicPr>
+          <p:nvPr/>
+        </p:nvPicPr>
+        <p:blipFill>
+          <a:blip r:embed="rId2"/>
+          <a:stretch>
+            <a:fillRect/>
+          </a:stretch>
+        </p:blipFill>
+        <p:spPr>
+          <a:xfrm>
+            <a:off x="1356284" y="1463040"/>
+            <a:ext cx="3794760" cy="3794760"/>
+          </a:xfrm>
+          <a:prstGeom prst="rect">
+            <a:avLst/>
+          </a:prstGeom>
+        </p:spPr>
+      </p:pic>
+      <p:sp>
+        <p:nvSpPr>
+          <p:cNvPr id="4" name="Rectangle 3"/>
+          <p:cNvSpPr/>
+          <p:nvPr/>
+        </p:nvSpPr>
+        <p:spPr>
+          <a:xfrm>
+            <a:off x="7040651" y="1463040"/>
+            <a:ext cx="3794760" cy="3794760"/>
+          </a:xfrm>
+          <a:prstGeom prst="rect">
+            <a:avLst/>
+          </a:prstGeom>
+          <a:solidFill>
+            <a:srgbClr val="FFFFFF"/>
+          </a:solidFill>
+          <a:ln w="28575">
+            <a:solidFill>
+              <a:srgbClr val="013169"/>
+            </a:solidFill>
+            <a:prstDash val="dash"/>
+          </a:ln>
+          <a:effectLst/>
+        </p:spPr>
+        <p:style>
+          <a:lnRef idx="1">
+            <a:schemeClr val="accent1"/>
+          </a:lnRef>
+          <a:fillRef idx="3">
+            <a:schemeClr val="accent1"/>
+          </a:fillRef>
+          <a:effectRef idx="2">
+            <a:schemeClr val="accent1"/>
+          </a:effectRef>
+          <a:fontRef idx="minor">
+            <a:schemeClr val="lt1"/>
+          </a:fontRef>
+        </p:style>
+        <p:txBody>
+          <a:bodyPr wrap="square" rtlCol="0" anchor="ctr"/>
+          <a:lstStyle/>
+          <a:p>
+            <a:pPr algn="ctr"/>
+            <a:r>
+              <a:rPr sz="2400" b="1">
+                <a:solidFill>
+                  <a:srgbClr val="013169"/>
+                </a:solidFill>
+                <a:latin typeface="Calibri"/>
+              </a:rPr>
+              <a:t>QR CODE</a:t>
+            </a:r>
+          </a:p>
+          <a:p>
+            <a:pPr algn="ctr"/>
+            <a:r>
+              <a:rPr sz="1400" i="1">
+                <a:solidFill>
+                  <a:srgbClr val="013169"/>
+                </a:solidFill>
+                <a:latin typeface="Calibri"/>
+              </a:rPr>
+              <a:t>Paste your Sessionize evaluation QR code here</a:t>
+            </a:r>
+          </a:p>
+        </p:txBody>
+      </p:sp>
+      <p:pic>
+        <p:nvPicPr>
+          <p:cNvPr id="5" name="Picture 4" descr="brug-logo.png"/>
+          <p:cNvPicPr>
+            <a:picLocks noChangeAspect="1"/>
+          </p:cNvPicPr>
+          <p:nvPr/>
+        </p:nvPicPr>
+        <p:blipFill>
+          <a:blip r:embed="rId3"/>
+          <a:stretch>
+            <a:fillRect/>
+          </a:stretch>
+        </p:blipFill>
+        <p:spPr>
+          <a:xfrm>
+            <a:off x="5332324" y="5486400"/>
+            <a:ext cx="1527048" cy="443117"/>
+          </a:xfrm>
+          <a:prstGeom prst="rect">
+            <a:avLst/>
+          </a:prstGeom>
+        </p:spPr>
+      </p:pic>
+      <p:pic>
+        <p:nvPicPr>
+          <p:cNvPr id="7" name="Picture 6">
+            <a:extLst>
+              <a:ext uri="{FF2B5EF4-FFF2-40B4-BE49-F238E27FC236}">
+                <a16:creationId xmlns:a16="http://schemas.microsoft.com/office/drawing/2014/main" id="{5B0281E3-6F40-4217-C280-DECB9E35DFFC}"/>
+              </a:ext>
+            </a:extLst>
+          </p:cNvPr>
+          <p:cNvPicPr>
+            <a:picLocks noChangeAspect="1"/>
+          </p:cNvPicPr>
+          <p:nvPr/>
+        </p:nvPicPr>
+        <p:blipFill>
+          <a:blip r:embed="rId4"/>
+          <a:stretch>
+            <a:fillRect/>
+          </a:stretch>
+        </p:blipFill>
+        <p:spPr>
+          <a:xfrm>
+            <a:off x="6985503" y="1407892"/>
+            <a:ext cx="3905056" cy="3905056"/>
+          </a:xfrm>
+          <a:prstGeom prst="rect">
+            <a:avLst/>
+          </a:prstGeom>
+        </p:spPr>
+      </p:pic>
+    </p:spTree>
+  </p:cSld>
+  <p:clrMapOvr>
+    <a:masterClrMapping/>
+  </p:clrMapOvr>
+</p:sld>
+</file>
+
 <file path=ppt/slides/slide3.xml><?xml version="1.0" encoding="utf-8"?>
+<p:sld xmlns:a="http://schemas.openxmlformats.org/drawingml/2006/main" xmlns:r="http://schemas.openxmlformats.org/officeDocument/2006/relationships" xmlns:p="http://schemas.openxmlformats.org/presentationml/2006/main">
+  <p:cSld>
+    <p:spTree>
+      <p:nvGrpSpPr>
+        <p:cNvPr id="1" name=""/>
+        <p:cNvGrpSpPr/>
+        <p:nvPr/>
+      </p:nvGrpSpPr>
+      <p:grpSpPr>
+        <a:xfrm>
+          <a:off x="0" y="0"/>
+          <a:ext cx="0" cy="0"/>
+          <a:chOff x="0" y="0"/>
+          <a:chExt cx="0" cy="0"/>
+        </a:xfrm>
+      </p:grpSpPr>
+      <p:sp>
+        <p:nvSpPr>
+          <p:cNvPr id="2" name="Rectangle 1"/>
+          <p:cNvSpPr/>
+          <p:nvPr/>
+        </p:nvSpPr>
+        <p:spPr>
+          <a:xfrm>
+            <a:off x="0" y="0"/>
+            <a:ext cx="12191695" cy="960120"/>
+          </a:xfrm>
+          <a:prstGeom prst="rect">
+            <a:avLst/>
+          </a:prstGeom>
+          <a:solidFill>
+            <a:srgbClr val="013169"/>
+          </a:solidFill>
+          <a:ln>
+            <a:noFill/>
+          </a:ln>
+          <a:effectLst/>
+        </p:spPr>
+        <p:style>
+          <a:lnRef idx="1">
+            <a:schemeClr val="accent1"/>
+          </a:lnRef>
+          <a:fillRef idx="3">
+            <a:schemeClr val="accent1"/>
+          </a:fillRef>
+          <a:effectRef idx="2">
+            <a:schemeClr val="accent1"/>
+          </a:effectRef>
+          <a:fontRef idx="minor">
+            <a:schemeClr val="lt1"/>
+          </a:fontRef>
+        </p:style>
+        <p:txBody>
+          <a:bodyPr rtlCol="0" anchor="ctr"/>
+          <a:lstStyle/>
+          <a:p>
+            <a:pPr algn="ctr"/>
+            <a:endParaRPr/>
+          </a:p>
+        </p:txBody>
+      </p:sp>
+      <p:sp>
+        <p:nvSpPr>
+          <p:cNvPr id="3" name="TextBox 2"/>
+          <p:cNvSpPr txBox="1"/>
+          <p:nvPr/>
+        </p:nvSpPr>
+        <p:spPr>
+          <a:xfrm>
+            <a:off x="0" y="128016"/>
+            <a:ext cx="12191695" cy="640080"/>
+          </a:xfrm>
+          <a:prstGeom prst="rect">
+            <a:avLst/>
+          </a:prstGeom>
+          <a:noFill/>
+        </p:spPr>
+        <p:txBody>
+          <a:bodyPr wrap="square" lIns="0" rIns="0" anchor="ctr">
+            <a:spAutoFit/>
+          </a:bodyPr>
+          <a:lstStyle/>
+          <a:p>
+            <a:pPr algn="ctr"/>
+            <a:r>
+              <a:rPr sz="3200">
+                <a:solidFill>
+                  <a:srgbClr val="FFFFFF"/>
+                </a:solidFill>
+                <a:latin typeface="Berlin Sans FB"/>
+              </a:rPr>
+              <a:t>Day of Data Baton Rouge 2026</a:t>
+            </a:r>
+          </a:p>
+        </p:txBody>
+      </p:sp>
+      <p:sp>
+        <p:nvSpPr>
+          <p:cNvPr id="4" name="Rectangle 3"/>
+          <p:cNvSpPr/>
+          <p:nvPr/>
+        </p:nvSpPr>
+        <p:spPr>
+          <a:xfrm>
+            <a:off x="0" y="6291072"/>
+            <a:ext cx="12191695" cy="612648"/>
+          </a:xfrm>
+          <a:prstGeom prst="rect">
+            <a:avLst/>
+          </a:prstGeom>
+          <a:solidFill>
+            <a:srgbClr val="F7C15D"/>
+          </a:solidFill>
+          <a:ln>
+            <a:noFill/>
+          </a:ln>
+          <a:effectLst/>
+        </p:spPr>
+        <p:style>
+          <a:lnRef idx="1">
+            <a:schemeClr val="accent1"/>
+          </a:lnRef>
+          <a:fillRef idx="3">
+            <a:schemeClr val="accent1"/>
+          </a:fillRef>
+          <a:effectRef idx="2">
+            <a:schemeClr val="accent1"/>
+          </a:effectRef>
+          <a:fontRef idx="minor">
+            <a:schemeClr val="lt1"/>
+          </a:fontRef>
+        </p:style>
+        <p:txBody>
+          <a:bodyPr rtlCol="0" anchor="ctr"/>
+          <a:lstStyle/>
+          <a:p>
+            <a:pPr algn="ctr"/>
+            <a:endParaRPr/>
+          </a:p>
+        </p:txBody>
+      </p:sp>
+      <p:sp>
+        <p:nvSpPr>
+          <p:cNvPr id="5" name="TextBox 4"/>
+          <p:cNvSpPr txBox="1"/>
+          <p:nvPr/>
+        </p:nvSpPr>
+        <p:spPr>
+          <a:xfrm>
+            <a:off x="0" y="6236208"/>
+            <a:ext cx="12191695" cy="585216"/>
+          </a:xfrm>
+          <a:prstGeom prst="rect">
+            <a:avLst/>
+          </a:prstGeom>
+          <a:noFill/>
+        </p:spPr>
+        <p:txBody>
+          <a:bodyPr wrap="square" lIns="0" rIns="0" anchor="ctr">
+            <a:spAutoFit/>
+          </a:bodyPr>
+          <a:lstStyle/>
+          <a:p>
+            <a:pPr algn="ctr"/>
+            <a:r>
+              <a:rPr sz="3200">
+                <a:solidFill>
+                  <a:srgbClr val="013169"/>
+                </a:solidFill>
+                <a:latin typeface="Berlin Sans FB"/>
+              </a:rPr>
+              <a:t>Thank You, Sponsors!</a:t>
+            </a:r>
+          </a:p>
+        </p:txBody>
+      </p:sp>
+      <p:pic>
+        <p:nvPicPr>
+          <p:cNvPr id="6" name="Picture 5" descr="sponsor1_cropped.png"/>
+          <p:cNvPicPr>
+            <a:picLocks noChangeAspect="1"/>
+          </p:cNvPicPr>
+          <p:nvPr/>
+        </p:nvPicPr>
+        <p:blipFill>
+          <a:blip r:embed="rId2"/>
+          <a:stretch>
+            <a:fillRect/>
+          </a:stretch>
+        </p:blipFill>
+        <p:spPr>
+          <a:xfrm>
+            <a:off x="429768" y="1635991"/>
+            <a:ext cx="1705813" cy="339898"/>
+          </a:xfrm>
+          <a:prstGeom prst="rect">
+            <a:avLst/>
+          </a:prstGeom>
+        </p:spPr>
+      </p:pic>
+      <p:pic>
+        <p:nvPicPr>
+          <p:cNvPr id="7" name="Picture 6" descr="sponsor2.png"/>
+          <p:cNvPicPr>
+            <a:picLocks noChangeAspect="1"/>
+          </p:cNvPicPr>
+          <p:nvPr/>
+        </p:nvPicPr>
+        <p:blipFill>
+          <a:blip r:embed="rId3"/>
+          <a:stretch>
+            <a:fillRect/>
+          </a:stretch>
+        </p:blipFill>
+        <p:spPr>
+          <a:xfrm>
+            <a:off x="2355037" y="1409338"/>
+            <a:ext cx="1705813" cy="793203"/>
+          </a:xfrm>
+          <a:prstGeom prst="rect">
+            <a:avLst/>
+          </a:prstGeom>
+        </p:spPr>
+      </p:pic>
+      <p:pic>
+        <p:nvPicPr>
+          <p:cNvPr id="8" name="Picture 7" descr="sponsor3_cropped.png"/>
+          <p:cNvPicPr>
+            <a:picLocks noChangeAspect="1"/>
+          </p:cNvPicPr>
+          <p:nvPr/>
+        </p:nvPicPr>
+        <p:blipFill>
+          <a:blip r:embed="rId4"/>
+          <a:stretch>
+            <a:fillRect/>
+          </a:stretch>
+        </p:blipFill>
+        <p:spPr>
+          <a:xfrm>
+            <a:off x="4280306" y="1441391"/>
+            <a:ext cx="1705813" cy="729098"/>
+          </a:xfrm>
+          <a:prstGeom prst="rect">
+            <a:avLst/>
+          </a:prstGeom>
+        </p:spPr>
+      </p:pic>
+      <p:pic>
+        <p:nvPicPr>
+          <p:cNvPr id="9" name="Picture 8" descr="sponsor4.jpg"/>
+          <p:cNvPicPr>
+            <a:picLocks noChangeAspect="1"/>
+          </p:cNvPicPr>
+          <p:nvPr/>
+        </p:nvPicPr>
+        <p:blipFill>
+          <a:blip r:embed="rId5"/>
+          <a:stretch>
+            <a:fillRect/>
+          </a:stretch>
+        </p:blipFill>
+        <p:spPr>
+          <a:xfrm>
+            <a:off x="6205576" y="1648152"/>
+            <a:ext cx="1705813" cy="315575"/>
+          </a:xfrm>
+          <a:prstGeom prst="rect">
+            <a:avLst/>
+          </a:prstGeom>
+        </p:spPr>
+      </p:pic>
+      <p:pic>
+        <p:nvPicPr>
+          <p:cNvPr id="10" name="Picture 9" descr="sponsor5_cropped.png"/>
+          <p:cNvPicPr>
+            <a:picLocks noChangeAspect="1"/>
+          </p:cNvPicPr>
+          <p:nvPr/>
+        </p:nvPicPr>
+        <p:blipFill>
+          <a:blip r:embed="rId6"/>
+          <a:stretch>
+            <a:fillRect/>
+          </a:stretch>
+        </p:blipFill>
+        <p:spPr>
+          <a:xfrm>
+            <a:off x="8130845" y="1603375"/>
+            <a:ext cx="1705813" cy="405131"/>
+          </a:xfrm>
+          <a:prstGeom prst="rect">
+            <a:avLst/>
+          </a:prstGeom>
+        </p:spPr>
+      </p:pic>
+      <p:pic>
+        <p:nvPicPr>
+          <p:cNvPr id="11" name="Picture 10" descr="sponsor6_cropped.png"/>
+          <p:cNvPicPr>
+            <a:picLocks noChangeAspect="1"/>
+          </p:cNvPicPr>
+          <p:nvPr/>
+        </p:nvPicPr>
+        <p:blipFill>
+          <a:blip r:embed="rId7"/>
+          <a:stretch>
+            <a:fillRect/>
+          </a:stretch>
+        </p:blipFill>
+        <p:spPr>
+          <a:xfrm>
+            <a:off x="10056114" y="1418686"/>
+            <a:ext cx="1705813" cy="774509"/>
+          </a:xfrm>
+          <a:prstGeom prst="rect">
+            <a:avLst/>
+          </a:prstGeom>
+        </p:spPr>
+      </p:pic>
+      <p:pic>
+        <p:nvPicPr>
+          <p:cNvPr id="12" name="Picture 11" descr="sponsor7.jpg"/>
+          <p:cNvPicPr>
+            <a:picLocks noChangeAspect="1"/>
+          </p:cNvPicPr>
+          <p:nvPr/>
+        </p:nvPicPr>
+        <p:blipFill>
+          <a:blip r:embed="rId8"/>
+          <a:stretch>
+            <a:fillRect/>
+          </a:stretch>
+        </p:blipFill>
+        <p:spPr>
+          <a:xfrm>
+            <a:off x="429768" y="2613927"/>
+            <a:ext cx="1705813" cy="852907"/>
+          </a:xfrm>
+          <a:prstGeom prst="rect">
+            <a:avLst/>
+          </a:prstGeom>
+        </p:spPr>
+      </p:pic>
+      <p:pic>
+        <p:nvPicPr>
+          <p:cNvPr id="13" name="Picture 12" descr="sponsor8_cropped.png"/>
+          <p:cNvPicPr>
+            <a:picLocks noChangeAspect="1"/>
+          </p:cNvPicPr>
+          <p:nvPr/>
+        </p:nvPicPr>
+        <p:blipFill>
+          <a:blip r:embed="rId9"/>
+          <a:stretch>
+            <a:fillRect/>
+          </a:stretch>
+        </p:blipFill>
+        <p:spPr>
+          <a:xfrm>
+            <a:off x="2722841" y="2532888"/>
+            <a:ext cx="970205" cy="1014984"/>
+          </a:xfrm>
+          <a:prstGeom prst="rect">
+            <a:avLst/>
+          </a:prstGeom>
+        </p:spPr>
+      </p:pic>
+      <p:pic>
+        <p:nvPicPr>
+          <p:cNvPr id="14" name="Picture 13" descr="sponsor9.jpg"/>
+          <p:cNvPicPr>
+            <a:picLocks noChangeAspect="1"/>
+          </p:cNvPicPr>
+          <p:nvPr/>
+        </p:nvPicPr>
+        <p:blipFill>
+          <a:blip r:embed="rId10"/>
+          <a:stretch>
+            <a:fillRect/>
+          </a:stretch>
+        </p:blipFill>
+        <p:spPr>
+          <a:xfrm>
+            <a:off x="4280306" y="2919907"/>
+            <a:ext cx="1705813" cy="240946"/>
+          </a:xfrm>
+          <a:prstGeom prst="rect">
+            <a:avLst/>
+          </a:prstGeom>
+        </p:spPr>
+      </p:pic>
+      <p:pic>
+        <p:nvPicPr>
+          <p:cNvPr id="15" name="Picture 14" descr="sponsor10_cropped.png"/>
+          <p:cNvPicPr>
+            <a:picLocks noChangeAspect="1"/>
+          </p:cNvPicPr>
+          <p:nvPr/>
+        </p:nvPicPr>
+        <p:blipFill>
+          <a:blip r:embed="rId11"/>
+          <a:stretch>
+            <a:fillRect/>
+          </a:stretch>
+        </p:blipFill>
+        <p:spPr>
+          <a:xfrm>
+            <a:off x="6205576" y="2704735"/>
+            <a:ext cx="1705813" cy="671290"/>
+          </a:xfrm>
+          <a:prstGeom prst="rect">
+            <a:avLst/>
+          </a:prstGeom>
+        </p:spPr>
+      </p:pic>
+      <p:pic>
+        <p:nvPicPr>
+          <p:cNvPr id="16" name="Picture 15" descr="sponsor11_cropped.png"/>
+          <p:cNvPicPr>
+            <a:picLocks noChangeAspect="1"/>
+          </p:cNvPicPr>
+          <p:nvPr/>
+        </p:nvPicPr>
+        <p:blipFill>
+          <a:blip r:embed="rId12"/>
+          <a:stretch>
+            <a:fillRect/>
+          </a:stretch>
+        </p:blipFill>
+        <p:spPr>
+          <a:xfrm>
+            <a:off x="8130845" y="2623884"/>
+            <a:ext cx="1705813" cy="832991"/>
+          </a:xfrm>
+          <a:prstGeom prst="rect">
+            <a:avLst/>
+          </a:prstGeom>
+        </p:spPr>
+      </p:pic>
+      <p:pic>
+        <p:nvPicPr>
+          <p:cNvPr id="17" name="Picture 16" descr="sponsor12_cropped.png"/>
+          <p:cNvPicPr>
+            <a:picLocks noChangeAspect="1"/>
+          </p:cNvPicPr>
+          <p:nvPr/>
+        </p:nvPicPr>
+        <p:blipFill>
+          <a:blip r:embed="rId13"/>
+          <a:stretch>
+            <a:fillRect/>
+          </a:stretch>
+        </p:blipFill>
+        <p:spPr>
+          <a:xfrm>
+            <a:off x="10486636" y="2532888"/>
+            <a:ext cx="844769" cy="1014984"/>
+          </a:xfrm>
+          <a:prstGeom prst="rect">
+            <a:avLst/>
+          </a:prstGeom>
+        </p:spPr>
+      </p:pic>
+      <p:pic>
+        <p:nvPicPr>
+          <p:cNvPr id="18" name="Picture 17" descr="sponsor13_cropped.png"/>
+          <p:cNvPicPr>
+            <a:picLocks noChangeAspect="1"/>
+          </p:cNvPicPr>
+          <p:nvPr/>
+        </p:nvPicPr>
+        <p:blipFill>
+          <a:blip r:embed="rId14"/>
+          <a:stretch>
+            <a:fillRect/>
+          </a:stretch>
+        </p:blipFill>
+        <p:spPr>
+          <a:xfrm>
+            <a:off x="429768" y="4148429"/>
+            <a:ext cx="1705813" cy="252782"/>
+          </a:xfrm>
+          <a:prstGeom prst="rect">
+            <a:avLst/>
+          </a:prstGeom>
+        </p:spPr>
+      </p:pic>
+      <p:pic>
+        <p:nvPicPr>
+          <p:cNvPr id="19" name="Picture 18" descr="sponsor14.png"/>
+          <p:cNvPicPr>
+            <a:picLocks noChangeAspect="1"/>
+          </p:cNvPicPr>
+          <p:nvPr/>
+        </p:nvPicPr>
+        <p:blipFill>
+          <a:blip r:embed="rId15"/>
+          <a:stretch>
+            <a:fillRect/>
+          </a:stretch>
+        </p:blipFill>
+        <p:spPr>
+          <a:xfrm>
+            <a:off x="2482955" y="3767328"/>
+            <a:ext cx="1449977" cy="1014984"/>
+          </a:xfrm>
+          <a:prstGeom prst="rect">
+            <a:avLst/>
+          </a:prstGeom>
+        </p:spPr>
+      </p:pic>
+      <p:pic>
+        <p:nvPicPr>
+          <p:cNvPr id="20" name="Picture 19" descr="sponsor15_cropped.png"/>
+          <p:cNvPicPr>
+            <a:picLocks noChangeAspect="1"/>
+          </p:cNvPicPr>
+          <p:nvPr/>
+        </p:nvPicPr>
+        <p:blipFill>
+          <a:blip r:embed="rId16"/>
+          <a:stretch>
+            <a:fillRect/>
+          </a:stretch>
+        </p:blipFill>
+        <p:spPr>
+          <a:xfrm>
+            <a:off x="4280306" y="4130846"/>
+            <a:ext cx="1705813" cy="287947"/>
+          </a:xfrm>
+          <a:prstGeom prst="rect">
+            <a:avLst/>
+          </a:prstGeom>
+        </p:spPr>
+      </p:pic>
+      <p:pic>
+        <p:nvPicPr>
+          <p:cNvPr id="21" name="Picture 20" descr="sponsor16_cropped.png"/>
+          <p:cNvPicPr>
+            <a:picLocks noChangeAspect="1"/>
+          </p:cNvPicPr>
+          <p:nvPr/>
+        </p:nvPicPr>
+        <p:blipFill>
+          <a:blip r:embed="rId17"/>
+          <a:stretch>
+            <a:fillRect/>
+          </a:stretch>
+        </p:blipFill>
+        <p:spPr>
+          <a:xfrm>
+            <a:off x="6205576" y="4006854"/>
+            <a:ext cx="1705813" cy="535932"/>
+          </a:xfrm>
+          <a:prstGeom prst="rect">
+            <a:avLst/>
+          </a:prstGeom>
+        </p:spPr>
+      </p:pic>
+      <p:pic>
+        <p:nvPicPr>
+          <p:cNvPr id="22" name="Picture 21" descr="sponsor17.png"/>
+          <p:cNvPicPr>
+            <a:picLocks noChangeAspect="1"/>
+          </p:cNvPicPr>
+          <p:nvPr/>
+        </p:nvPicPr>
+        <p:blipFill>
+          <a:blip r:embed="rId18"/>
+          <a:stretch>
+            <a:fillRect/>
+          </a:stretch>
+        </p:blipFill>
+        <p:spPr>
+          <a:xfrm>
+            <a:off x="8130845" y="4168207"/>
+            <a:ext cx="1705813" cy="213227"/>
+          </a:xfrm>
+          <a:prstGeom prst="rect">
+            <a:avLst/>
+          </a:prstGeom>
+        </p:spPr>
+      </p:pic>
+      <p:pic>
+        <p:nvPicPr>
+          <p:cNvPr id="23" name="Picture 22" descr="sponsor18_cropped.png"/>
+          <p:cNvPicPr>
+            <a:picLocks noChangeAspect="1"/>
+          </p:cNvPicPr>
+          <p:nvPr/>
+        </p:nvPicPr>
+        <p:blipFill>
+          <a:blip r:embed="rId19"/>
+          <a:stretch>
+            <a:fillRect/>
+          </a:stretch>
+        </p:blipFill>
+        <p:spPr>
+          <a:xfrm>
+            <a:off x="10100793" y="3767328"/>
+            <a:ext cx="1616456" cy="1014984"/>
+          </a:xfrm>
+          <a:prstGeom prst="rect">
+            <a:avLst/>
+          </a:prstGeom>
+        </p:spPr>
+      </p:pic>
+      <p:pic>
+        <p:nvPicPr>
+          <p:cNvPr id="24" name="Picture 23" descr="sponsor19_cropped.png"/>
+          <p:cNvPicPr>
+            <a:picLocks noChangeAspect="1"/>
+          </p:cNvPicPr>
+          <p:nvPr/>
+        </p:nvPicPr>
+        <p:blipFill>
+          <a:blip r:embed="rId20"/>
+          <a:stretch>
+            <a:fillRect/>
+          </a:stretch>
+        </p:blipFill>
+        <p:spPr>
+          <a:xfrm>
+            <a:off x="429768" y="5170658"/>
+            <a:ext cx="2090867" cy="677204"/>
+          </a:xfrm>
+          <a:prstGeom prst="rect">
+            <a:avLst/>
+          </a:prstGeom>
+        </p:spPr>
+      </p:pic>
+      <p:pic>
+        <p:nvPicPr>
+          <p:cNvPr id="25" name="Picture 24" descr="sponsor20_cropped.png"/>
+          <p:cNvPicPr>
+            <a:picLocks noChangeAspect="1"/>
+          </p:cNvPicPr>
+          <p:nvPr/>
+        </p:nvPicPr>
+        <p:blipFill>
+          <a:blip r:embed="rId21"/>
+          <a:stretch>
+            <a:fillRect/>
+          </a:stretch>
+        </p:blipFill>
+        <p:spPr>
+          <a:xfrm>
+            <a:off x="2990971" y="5001768"/>
+            <a:ext cx="1589108" cy="1014984"/>
+          </a:xfrm>
+          <a:prstGeom prst="rect">
+            <a:avLst/>
+          </a:prstGeom>
+        </p:spPr>
+      </p:pic>
+      <p:pic>
+        <p:nvPicPr>
+          <p:cNvPr id="26" name="Picture 25" descr="sponsor21_cropped.png"/>
+          <p:cNvPicPr>
+            <a:picLocks noChangeAspect="1"/>
+          </p:cNvPicPr>
+          <p:nvPr/>
+        </p:nvPicPr>
+        <p:blipFill>
+          <a:blip r:embed="rId22"/>
+          <a:stretch>
+            <a:fillRect/>
+          </a:stretch>
+        </p:blipFill>
+        <p:spPr>
+          <a:xfrm>
+            <a:off x="5594415" y="5001768"/>
+            <a:ext cx="1002865" cy="1014984"/>
+          </a:xfrm>
+          <a:prstGeom prst="rect">
+            <a:avLst/>
+          </a:prstGeom>
+        </p:spPr>
+      </p:pic>
+      <p:pic>
+        <p:nvPicPr>
+          <p:cNvPr id="27" name="Picture 26" descr="sponsor22_cropped.png"/>
+          <p:cNvPicPr>
+            <a:picLocks noChangeAspect="1"/>
+          </p:cNvPicPr>
+          <p:nvPr/>
+        </p:nvPicPr>
+        <p:blipFill>
+          <a:blip r:embed="rId23"/>
+          <a:stretch>
+            <a:fillRect/>
+          </a:stretch>
+        </p:blipFill>
+        <p:spPr>
+          <a:xfrm>
+            <a:off x="7652622" y="5001768"/>
+            <a:ext cx="1507097" cy="1014984"/>
+          </a:xfrm>
+          <a:prstGeom prst="rect">
+            <a:avLst/>
+          </a:prstGeom>
+        </p:spPr>
+      </p:pic>
+      <p:pic>
+        <p:nvPicPr>
+          <p:cNvPr id="28" name="Picture 27" descr="sponsor23_cropped.png"/>
+          <p:cNvPicPr>
+            <a:picLocks noChangeAspect="1"/>
+          </p:cNvPicPr>
+          <p:nvPr/>
+        </p:nvPicPr>
+        <p:blipFill>
+          <a:blip r:embed="rId24"/>
+          <a:stretch>
+            <a:fillRect/>
+          </a:stretch>
+        </p:blipFill>
+        <p:spPr>
+          <a:xfrm>
+            <a:off x="9671060" y="5309157"/>
+            <a:ext cx="2090867" cy="400205"/>
+          </a:xfrm>
+          <a:prstGeom prst="rect">
+            <a:avLst/>
+          </a:prstGeom>
+        </p:spPr>
+      </p:pic>
+    </p:spTree>
+  </p:cSld>
+  <p:clrMapOvr>
+    <a:masterClrMapping/>
+  </p:clrMapOvr>
+</p:sld>
+</file>
+
+<file path=ppt/slides/slide4.xml><?xml version="1.0" encoding="utf-8"?>
 <p:sld xmlns:a="http://schemas.openxmlformats.org/drawingml/2006/main" xmlns:r="http://schemas.openxmlformats.org/officeDocument/2006/relationships" xmlns:p="http://schemas.openxmlformats.org/presentationml/2006/main">
   <p:cSld>
     <p:bg>
@@ -24126,7 +25445,7 @@
 </p:sld>
 </file>
 
-<file path=ppt/slides/slide4.xml><?xml version="1.0" encoding="utf-8"?>
+<file path=ppt/slides/slide5.xml><?xml version="1.0" encoding="utf-8"?>
 <p:sld xmlns:a="http://schemas.openxmlformats.org/drawingml/2006/main" xmlns:r="http://schemas.openxmlformats.org/officeDocument/2006/relationships" xmlns:p="http://schemas.openxmlformats.org/presentationml/2006/main">
   <p:cSld>
     <p:bg>
@@ -24784,7 +26103,7 @@
 </p:sld>
 </file>
 
-<file path=ppt/slides/slide5.xml><?xml version="1.0" encoding="utf-8"?>
+<file path=ppt/slides/slide6.xml><?xml version="1.0" encoding="utf-8"?>
 <p:sld xmlns:a="http://schemas.openxmlformats.org/drawingml/2006/main" xmlns:r="http://schemas.openxmlformats.org/officeDocument/2006/relationships" xmlns:p="http://schemas.openxmlformats.org/presentationml/2006/main">
   <p:cSld>
     <p:bg>
@@ -25305,7 +26624,7 @@
 </p:sld>
 </file>
 
-<file path=ppt/slides/slide6.xml><?xml version="1.0" encoding="utf-8"?>
+<file path=ppt/slides/slide7.xml><?xml version="1.0" encoding="utf-8"?>
 <p:sld xmlns:a="http://schemas.openxmlformats.org/drawingml/2006/main" xmlns:r="http://schemas.openxmlformats.org/officeDocument/2006/relationships" xmlns:p="http://schemas.openxmlformats.org/presentationml/2006/main">
   <p:cSld>
     <p:bg>
@@ -26620,7 +27939,7 @@
 </p:sld>
 </file>
 
-<file path=ppt/slides/slide7.xml><?xml version="1.0" encoding="utf-8"?>
+<file path=ppt/slides/slide8.xml><?xml version="1.0" encoding="utf-8"?>
 <p:sld xmlns:a="http://schemas.openxmlformats.org/drawingml/2006/main" xmlns:r="http://schemas.openxmlformats.org/officeDocument/2006/relationships" xmlns:p="http://schemas.openxmlformats.org/presentationml/2006/main">
   <p:cSld>
     <p:bg>
@@ -27259,7 +28578,7 @@
 </p:sld>
 </file>
 
-<file path=ppt/slides/slide8.xml><?xml version="1.0" encoding="utf-8"?>
+<file path=ppt/slides/slide9.xml><?xml version="1.0" encoding="utf-8"?>
 <p:sld xmlns:a="http://schemas.openxmlformats.org/drawingml/2006/main" xmlns:r="http://schemas.openxmlformats.org/officeDocument/2006/relationships" xmlns:p="http://schemas.openxmlformats.org/presentationml/2006/main">
   <p:cSld>
     <p:bg>
@@ -27666,460 +28985,6 @@
               <a:buNone/>
             </a:pPr>
             <a:endParaRPr/>
-          </a:p>
-        </p:txBody>
-      </p:sp>
-    </p:spTree>
-  </p:cSld>
-  <p:clrMapOvr>
-    <a:masterClrMapping/>
-  </p:clrMapOvr>
-</p:sld>
-</file>
-
-<file path=ppt/slides/slide9.xml><?xml version="1.0" encoding="utf-8"?>
-<p:sld xmlns:a="http://schemas.openxmlformats.org/drawingml/2006/main" xmlns:r="http://schemas.openxmlformats.org/officeDocument/2006/relationships" xmlns:p="http://schemas.openxmlformats.org/presentationml/2006/main">
-  <p:cSld>
-    <p:bg>
-      <p:bgPr>
-        <a:solidFill>
-          <a:schemeClr val="lt1"/>
-        </a:solidFill>
-        <a:effectLst/>
-      </p:bgPr>
-    </p:bg>
-    <p:spTree>
-      <p:nvGrpSpPr>
-        <p:cNvPr id="1" name="Shape 237"/>
-        <p:cNvGrpSpPr/>
-        <p:nvPr/>
-      </p:nvGrpSpPr>
-      <p:grpSpPr>
-        <a:xfrm>
-          <a:off x="0" y="0"/>
-          <a:ext cx="0" cy="0"/>
-          <a:chOff x="0" y="0"/>
-          <a:chExt cx="0" cy="0"/>
-        </a:xfrm>
-      </p:grpSpPr>
-      <p:sp>
-        <p:nvSpPr>
-          <p:cNvPr id="238" name="Google Shape;238;p10"/>
-          <p:cNvSpPr/>
-          <p:nvPr/>
-        </p:nvSpPr>
-        <p:spPr>
-          <a:xfrm flipH="1">
-            <a:off x="-3" y="-1"/>
-            <a:ext cx="12192000" cy="1590600"/>
-          </a:xfrm>
-          <a:prstGeom prst="rect">
-            <a:avLst/>
-          </a:prstGeom>
-          <a:gradFill>
-            <a:gsLst>
-              <a:gs pos="0">
-                <a:srgbClr val="000000"/>
-              </a:gs>
-              <a:gs pos="100000">
-                <a:srgbClr val="2F5496"/>
-              </a:gs>
-            </a:gsLst>
-            <a:lin ang="8400134" scaled="0"/>
-          </a:gradFill>
-          <a:ln>
-            <a:noFill/>
-          </a:ln>
-        </p:spPr>
-        <p:txBody>
-          <a:bodyPr spcFirstLastPara="1" wrap="square" lIns="91425" tIns="45700" rIns="91425" bIns="45700" anchor="ctr" anchorCtr="0">
-            <a:noAutofit/>
-          </a:bodyPr>
-          <a:lstStyle/>
-          <a:p>
-            <a:pPr marL="0" marR="0" lvl="0" indent="0" algn="ctr" rtl="0">
-              <a:spcBef>
-                <a:spcPts val="0"/>
-              </a:spcBef>
-              <a:spcAft>
-                <a:spcPts val="0"/>
-              </a:spcAft>
-              <a:buNone/>
-            </a:pPr>
-            <a:endParaRPr sz="1800" b="0" i="0" u="none" strike="noStrike" cap="none">
-              <a:solidFill>
-                <a:schemeClr val="lt1"/>
-              </a:solidFill>
-              <a:latin typeface="Calibri"/>
-              <a:ea typeface="Calibri"/>
-              <a:cs typeface="Calibri"/>
-              <a:sym typeface="Calibri"/>
-            </a:endParaRPr>
-          </a:p>
-        </p:txBody>
-      </p:sp>
-      <p:sp>
-        <p:nvSpPr>
-          <p:cNvPr id="239" name="Google Shape;239;p10"/>
-          <p:cNvSpPr/>
-          <p:nvPr/>
-        </p:nvSpPr>
-        <p:spPr>
-          <a:xfrm rot="10800000" flipH="1">
-            <a:off x="-3" y="142"/>
-            <a:ext cx="8115300" cy="1590600"/>
-          </a:xfrm>
-          <a:prstGeom prst="rect">
-            <a:avLst/>
-          </a:prstGeom>
-          <a:gradFill>
-            <a:gsLst>
-              <a:gs pos="0">
-                <a:srgbClr val="4472C4">
-                  <a:alpha val="0"/>
-                </a:srgbClr>
-              </a:gs>
-              <a:gs pos="20000">
-                <a:srgbClr val="4472C4">
-                  <a:alpha val="0"/>
-                </a:srgbClr>
-              </a:gs>
-              <a:gs pos="100000">
-                <a:srgbClr val="1F3864">
-                  <a:alpha val="54901"/>
-                </a:srgbClr>
-              </a:gs>
-            </a:gsLst>
-            <a:lin ang="13800146" scaled="0"/>
-          </a:gradFill>
-          <a:ln>
-            <a:noFill/>
-          </a:ln>
-        </p:spPr>
-        <p:txBody>
-          <a:bodyPr spcFirstLastPara="1" wrap="square" lIns="91425" tIns="45700" rIns="91425" bIns="45700" anchor="ctr" anchorCtr="0">
-            <a:noAutofit/>
-          </a:bodyPr>
-          <a:lstStyle/>
-          <a:p>
-            <a:pPr marL="0" marR="0" lvl="0" indent="0" algn="ctr" rtl="0">
-              <a:spcBef>
-                <a:spcPts val="0"/>
-              </a:spcBef>
-              <a:spcAft>
-                <a:spcPts val="0"/>
-              </a:spcAft>
-              <a:buNone/>
-            </a:pPr>
-            <a:endParaRPr sz="1800" b="0" i="0" u="none" strike="noStrike" cap="none">
-              <a:solidFill>
-                <a:schemeClr val="lt1"/>
-              </a:solidFill>
-              <a:latin typeface="Calibri"/>
-              <a:ea typeface="Calibri"/>
-              <a:cs typeface="Calibri"/>
-              <a:sym typeface="Calibri"/>
-            </a:endParaRPr>
-          </a:p>
-        </p:txBody>
-      </p:sp>
-      <p:sp>
-        <p:nvSpPr>
-          <p:cNvPr id="240" name="Google Shape;240;p10"/>
-          <p:cNvSpPr txBox="1">
-            <a:spLocks noGrp="1"/>
-          </p:cNvSpPr>
-          <p:nvPr>
-            <p:ph type="title"/>
-          </p:nvPr>
-        </p:nvSpPr>
-        <p:spPr>
-          <a:xfrm>
-            <a:off x="1371597" y="348865"/>
-            <a:ext cx="10044000" cy="877800"/>
-          </a:xfrm>
-          <a:prstGeom prst="rect">
-            <a:avLst/>
-          </a:prstGeom>
-          <a:noFill/>
-          <a:ln>
-            <a:noFill/>
-          </a:ln>
-        </p:spPr>
-        <p:txBody>
-          <a:bodyPr spcFirstLastPara="1" wrap="square" lIns="91425" tIns="45700" rIns="91425" bIns="45700" anchor="ctr" anchorCtr="0">
-            <a:normAutofit/>
-          </a:bodyPr>
-          <a:lstStyle/>
-          <a:p>
-            <a:pPr marL="0" lvl="0" indent="0" algn="l" rtl="0">
-              <a:lnSpc>
-                <a:spcPct val="90000"/>
-              </a:lnSpc>
-              <a:spcBef>
-                <a:spcPts val="0"/>
-              </a:spcBef>
-              <a:spcAft>
-                <a:spcPts val="0"/>
-              </a:spcAft>
-              <a:buClr>
-                <a:srgbClr val="FFFFFF"/>
-              </a:buClr>
-              <a:buSzPts val="4000"/>
-              <a:buFont typeface="Calibri"/>
-              <a:buNone/>
-            </a:pPr>
-            <a:r>
-              <a:rPr lang="en-US" sz="4000">
-                <a:solidFill>
-                  <a:srgbClr val="FFFFFF"/>
-                </a:solidFill>
-                <a:latin typeface="Calibri"/>
-                <a:ea typeface="Calibri"/>
-                <a:cs typeface="Calibri"/>
-                <a:sym typeface="Calibri"/>
-              </a:rPr>
-              <a:t>Variables</a:t>
-            </a:r>
-            <a:endParaRPr/>
-          </a:p>
-        </p:txBody>
-      </p:sp>
-      <p:sp>
-        <p:nvSpPr>
-          <p:cNvPr id="241" name="Google Shape;241;p10"/>
-          <p:cNvSpPr txBox="1">
-            <a:spLocks noGrp="1"/>
-          </p:cNvSpPr>
-          <p:nvPr>
-            <p:ph type="body" idx="2"/>
-          </p:nvPr>
-        </p:nvSpPr>
-        <p:spPr>
-          <a:xfrm>
-            <a:off x="1166297" y="2112579"/>
-            <a:ext cx="4872919" cy="4089712"/>
-          </a:xfrm>
-          <a:prstGeom prst="rect">
-            <a:avLst/>
-          </a:prstGeom>
-          <a:noFill/>
-          <a:ln>
-            <a:noFill/>
-          </a:ln>
-        </p:spPr>
-        <p:txBody>
-          <a:bodyPr spcFirstLastPara="1" wrap="square" lIns="91425" tIns="45700" rIns="91425" bIns="45700" anchor="t" anchorCtr="0">
-            <a:normAutofit/>
-          </a:bodyPr>
-          <a:lstStyle/>
-          <a:p>
-            <a:pPr marL="212598" lvl="0" indent="-212343" algn="l" rtl="0">
-              <a:lnSpc>
-                <a:spcPct val="90000"/>
-              </a:lnSpc>
-              <a:spcBef>
-                <a:spcPts val="0"/>
-              </a:spcBef>
-              <a:spcAft>
-                <a:spcPts val="0"/>
-              </a:spcAft>
-              <a:buClr>
-                <a:schemeClr val="dk1"/>
-              </a:buClr>
-              <a:buSzPts val="2600"/>
-              <a:buChar char="•"/>
-            </a:pPr>
-            <a:r>
-              <a:rPr lang="en-US" sz="2600" dirty="0">
-                <a:solidFill>
-                  <a:schemeClr val="dk1"/>
-                </a:solidFill>
-                <a:latin typeface="Calibri"/>
-                <a:ea typeface="Calibri"/>
-                <a:cs typeface="Calibri"/>
-                <a:sym typeface="Calibri"/>
-              </a:rPr>
-              <a:t>Names start with a $</a:t>
-            </a:r>
-            <a:endParaRPr sz="2600" dirty="0"/>
-          </a:p>
-          <a:p>
-            <a:pPr marL="212598" lvl="0" indent="-212343" algn="l" rtl="0">
-              <a:lnSpc>
-                <a:spcPct val="90000"/>
-              </a:lnSpc>
-              <a:spcBef>
-                <a:spcPts val="930"/>
-              </a:spcBef>
-              <a:spcAft>
-                <a:spcPts val="0"/>
-              </a:spcAft>
-              <a:buClr>
-                <a:schemeClr val="dk1"/>
-              </a:buClr>
-              <a:buSzPts val="2600"/>
-              <a:buChar char="•"/>
-            </a:pPr>
-            <a:r>
-              <a:rPr lang="en-US" sz="2600" dirty="0">
-                <a:solidFill>
-                  <a:schemeClr val="dk1"/>
-                </a:solidFill>
-                <a:latin typeface="Calibri"/>
-                <a:ea typeface="Calibri"/>
-                <a:cs typeface="Calibri"/>
-                <a:sym typeface="Calibri"/>
-              </a:rPr>
-              <a:t>Names are not case sensitive</a:t>
-            </a:r>
-            <a:endParaRPr sz="2600" dirty="0"/>
-          </a:p>
-          <a:p>
-            <a:pPr marL="212598" lvl="0" indent="-212343" algn="l" rtl="0">
-              <a:lnSpc>
-                <a:spcPct val="90000"/>
-              </a:lnSpc>
-              <a:spcBef>
-                <a:spcPts val="930"/>
-              </a:spcBef>
-              <a:spcAft>
-                <a:spcPts val="0"/>
-              </a:spcAft>
-              <a:buClr>
-                <a:schemeClr val="dk1"/>
-              </a:buClr>
-              <a:buSzPts val="2600"/>
-              <a:buChar char="•"/>
-            </a:pPr>
-            <a:r>
-              <a:rPr lang="en-US" sz="2600" dirty="0">
-                <a:solidFill>
-                  <a:schemeClr val="dk1"/>
-                </a:solidFill>
-                <a:latin typeface="Calibri"/>
-                <a:ea typeface="Calibri"/>
-                <a:cs typeface="Calibri"/>
-                <a:sym typeface="Calibri"/>
-              </a:rPr>
-              <a:t>Can contain numbers and letters</a:t>
-            </a:r>
-            <a:endParaRPr sz="2600" dirty="0"/>
-          </a:p>
-          <a:p>
-            <a:pPr marL="212598" lvl="0" indent="-212343" algn="l" rtl="0">
-              <a:lnSpc>
-                <a:spcPct val="90000"/>
-              </a:lnSpc>
-              <a:spcBef>
-                <a:spcPts val="930"/>
-              </a:spcBef>
-              <a:spcAft>
-                <a:spcPts val="0"/>
-              </a:spcAft>
-              <a:buClr>
-                <a:schemeClr val="dk1"/>
-              </a:buClr>
-              <a:buSzPts val="2600"/>
-              <a:buChar char="•"/>
-            </a:pPr>
-            <a:r>
-              <a:rPr lang="en-US" sz="2600" dirty="0"/>
-              <a:t>Variables have multiple scopes:</a:t>
-            </a:r>
-            <a:endParaRPr sz="2600" dirty="0"/>
-          </a:p>
-          <a:p>
-            <a:pPr marL="669798" lvl="1" indent="-225298" algn="l" rtl="0">
-              <a:lnSpc>
-                <a:spcPct val="90000"/>
-              </a:lnSpc>
-              <a:spcBef>
-                <a:spcPts val="930"/>
-              </a:spcBef>
-              <a:spcAft>
-                <a:spcPts val="0"/>
-              </a:spcAft>
-              <a:buClr>
-                <a:schemeClr val="dk1"/>
-              </a:buClr>
-              <a:buSzPts val="2600"/>
-              <a:buChar char="•"/>
-            </a:pPr>
-            <a:r>
-              <a:rPr lang="en-US" sz="2600" dirty="0"/>
-              <a:t>Global</a:t>
-            </a:r>
-            <a:endParaRPr sz="2600" dirty="0"/>
-          </a:p>
-          <a:p>
-            <a:pPr marL="669798" lvl="1" indent="-225298" algn="l" rtl="0">
-              <a:lnSpc>
-                <a:spcPct val="90000"/>
-              </a:lnSpc>
-              <a:spcBef>
-                <a:spcPts val="930"/>
-              </a:spcBef>
-              <a:spcAft>
-                <a:spcPts val="0"/>
-              </a:spcAft>
-              <a:buClr>
-                <a:schemeClr val="dk1"/>
-              </a:buClr>
-              <a:buSzPts val="2600"/>
-              <a:buChar char="•"/>
-            </a:pPr>
-            <a:r>
-              <a:rPr lang="en-US" sz="2600" dirty="0"/>
-              <a:t>Local</a:t>
-            </a:r>
-            <a:endParaRPr sz="2600" dirty="0"/>
-          </a:p>
-          <a:p>
-            <a:pPr marL="669798" lvl="1" indent="-225298" algn="l" rtl="0">
-              <a:lnSpc>
-                <a:spcPct val="90000"/>
-              </a:lnSpc>
-              <a:spcBef>
-                <a:spcPts val="930"/>
-              </a:spcBef>
-              <a:spcAft>
-                <a:spcPts val="0"/>
-              </a:spcAft>
-              <a:buClr>
-                <a:schemeClr val="dk1"/>
-              </a:buClr>
-              <a:buSzPts val="2600"/>
-              <a:buChar char="•"/>
-            </a:pPr>
-            <a:r>
-              <a:rPr lang="en-US" sz="2600" dirty="0"/>
-              <a:t>Script</a:t>
-            </a:r>
-            <a:endParaRPr sz="2600" dirty="0"/>
-          </a:p>
-          <a:p>
-            <a:pPr marL="669798" lvl="1" indent="-225298" algn="l" rtl="0">
-              <a:lnSpc>
-                <a:spcPct val="90000"/>
-              </a:lnSpc>
-              <a:spcBef>
-                <a:spcPts val="930"/>
-              </a:spcBef>
-              <a:spcAft>
-                <a:spcPts val="0"/>
-              </a:spcAft>
-              <a:buClr>
-                <a:schemeClr val="dk1"/>
-              </a:buClr>
-              <a:buSzPts val="2600"/>
-              <a:buChar char="•"/>
-            </a:pPr>
-            <a:r>
-              <a:rPr lang="en-US" sz="2600" dirty="0"/>
-              <a:t>Private (not really a scope)</a:t>
-            </a:r>
-            <a:endParaRPr sz="2600" dirty="0"/>
           </a:p>
         </p:txBody>
       </p:sp>

</xml_diff>